<commit_message>
Complete PPT Ch02 ML1 Design assignment
- Step 2: Title formatting (Black, Bold, size 66) on slides 2, 4, 6, 8
- Step 3: Text box 'Make it' on slide 3 (font 80, pos 0.73x0.73)
- Step 4: Rectangle shape on slide 3 (3.9x3.9, Intense Effect Orange Accent 1, Preset 2)
- Step 5: Reflected Perspective Right picture style on slide 5
- Step 6: Numbered circle icons (1-4) on slide 10 with Offset Bottom shadow
- Steps 7-8: Fly In animation on slides 2, 4, 6, 8 (duration 0.75, delay 0.50)
- Step 9-10: Grow/Shrink emphasis on 'Adds Emphasis' text, reordered
- Step 11: Cube transition (From Bottom) on all slides
- Step 12: Welcome.m4a audio on slide 1 (auto-play, hide during show)

Co-authored-by: melaniecailao23-max <300766327+melaniecailao23-max@users.noreply.github.com>
</commit_message>
<xml_diff>
--- a/Cailao_Exp22_PPT_Ch02_ML1_Design.pptx
+++ b/Cailao_Exp22_PPT_Ch02_ML1_Design.pptx
@@ -5203,7 +5203,7 @@
 </file>
 
 <file path=ppt/slides/slide1.xml><?xml version="1.0" encoding="utf-8"?>
-<p:sld xmlns:a="http://schemas.openxmlformats.org/drawingml/2006/main" xmlns:r="http://schemas.openxmlformats.org/officeDocument/2006/relationships" xmlns:p="http://schemas.openxmlformats.org/presentationml/2006/main">
+<p:sld xmlns:a="http://schemas.openxmlformats.org/drawingml/2006/main" xmlns:a14="http://schemas.microsoft.com/office/drawing/2010/main" xmlns:a16="http://schemas.microsoft.com/office/drawing/2014/main" xmlns:p="http://schemas.openxmlformats.org/presentationml/2006/main" xmlns:p14="http://schemas.microsoft.com/office/powerpoint/2010/main" xmlns:r="http://schemas.openxmlformats.org/officeDocument/2006/relationships">
   <p:cSld>
     <p:bg>
       <p:bgPr>
@@ -5212,7 +5212,7 @@
             <a:lum/>
             <a:extLst>
               <a:ext uri="{28A0092B-C50C-407E-A947-70E740481C1C}">
-                <a14:useLocalDpi xmlns:a14="http://schemas.microsoft.com/office/drawing/2010/main"/>
+                <a14:useLocalDpi/>
               </a:ext>
             </a:extLst>
           </a:blip>
@@ -5243,7 +5243,7 @@
           <p:cNvPr id="2" name="Title 1" descr="gG5PYCIQRSuPQ9CRjsNMxFqEoDHNMLkSku5ep5f7liUc46NNuryjp0eBaznCg9o1SJhvoBmxmNco91RFkl4dxS16kZgTdWUq-~Xags+/XlXULCXDC4z7sD1g==">
             <a:extLst>
               <a:ext uri="{FF2B5EF4-FFF2-40B4-BE49-F238E27FC236}">
-                <a16:creationId xmlns:a16="http://schemas.microsoft.com/office/drawing/2014/main" id="{782D1831-EFAC-49BC-944C-9B62206FB65C}"/>
+                <a16:creationId id="{782D1831-EFAC-49BC-944C-9B62206FB65C}"/>
               </a:ext>
             </a:extLst>
           </p:cNvPr>
@@ -5282,7 +5282,7 @@
           <p:cNvPr id="3" name="Subtitle 2" descr="R8CXuNSZfELzfkCU9/iPy0fY36ZKc2cnVHeDpUzkFhY4cbtGSRB9Gq6Gx2j4Ws71oy16qZ6vsbP5HmvlODiaT73UYr2xlu1j-~b1ytmLhJn41nl2d1VfGQ4w==">
             <a:extLst>
               <a:ext uri="{FF2B5EF4-FFF2-40B4-BE49-F238E27FC236}">
-                <a16:creationId xmlns:a16="http://schemas.microsoft.com/office/drawing/2014/main" id="{158A7B35-19F4-44FE-945D-A3590741D6BD}"/>
+                <a16:creationId id="{158A7B35-19F4-44FE-945D-A3590741D6BD}"/>
               </a:ext>
             </a:extLst>
           </p:cNvPr>
@@ -5315,21 +5315,120 @@
           </a:p>
         </p:txBody>
       </p:sp>
+      <p:pic>
+        <p:nvPicPr>
+          <p:cNvPr id="300" name="Welcome.m4a"/>
+          <p:cNvPicPr>
+            <a:picLocks noChangeAspect="1"/>
+          </p:cNvPicPr>
+          <p:nvPr>
+            <a:audioFile r:link="rId4"/>
+            <p:extLst>
+              <p:ext uri="{DAA4B4D4-6D71-4841-9C94-3DE7FCFB9230}">
+                <p14:media r:embed="rId5"/>
+              </p:ext>
+            </p:extLst>
+          </p:nvPr>
+        </p:nvPicPr>
+        <p:blipFill>
+          <a:blip/>
+          <a:stretch>
+            <a:fillRect/>
+          </a:stretch>
+        </p:blipFill>
+        <p:spPr>
+          <a:xfrm>
+            <a:off x="219456" y="219456"/>
+            <a:ext cx="274320" cy="274320"/>
+          </a:xfrm>
+          <a:prstGeom prst="rect">
+            <a:avLst/>
+          </a:prstGeom>
+        </p:spPr>
+      </p:pic>
     </p:spTree>
     <p:extLst>
       <p:ext uri="{BB962C8B-B14F-4D97-AF65-F5344CB8AC3E}">
-        <p14:creationId xmlns:p14="http://schemas.microsoft.com/office/powerpoint/2010/main" val="2592833662"/>
+        <p14:creationId val="2592833662"/>
       </p:ext>
     </p:extLst>
   </p:cSld>
   <p:clrMapOvr>
     <a:masterClrMapping/>
   </p:clrMapOvr>
+  <p:transition>
+    <p14:cube dir="d"/>
+  </p:transition>
+  <p:timing>
+    <p:tnLst>
+      <p:par>
+        <p:cTn id="1" dur="indefinite" restart="never" nodeType="tmRoot">
+          <p:childTnLst>
+            <p:seq concurrent="1" nextAc="seek">
+              <p:cTn id="2" dur="indefinite" nodeType="mainSeq">
+                <p:childTnLst>
+                  <p:par>
+                    <p:cTn id="3" fill="hold">
+                      <p:stCondLst>
+                        <p:cond delay="0"/>
+                      </p:stCondLst>
+                      <p:childTnLst>
+                        <p:par>
+                          <p:cTn id="4" fill="hold">
+                            <p:stCondLst>
+                              <p:cond delay="0"/>
+                            </p:stCondLst>
+                            <p:childTnLst>
+                              <p:par>
+                                <p:cTn id="5" presetID="1" presetClass="mediacall" presetSubtype="0" fill="hold" nodeType="afterEffect">
+                                  <p:stCondLst>
+                                    <p:cond delay="0"/>
+                                  </p:stCondLst>
+                                  <p:childTnLst>
+                                    <p:cmd type="call" cmd="playFrom(0)">
+                                      <p:cBhvr>
+                                        <p:cTn id="6" dur="1" fill="hold"/>
+                                        <p:tgtEl>
+                                          <p:spTgt spid="300"/>
+                                        </p:tgtEl>
+                                      </p:cBhvr>
+                                    </p:cmd>
+                                  </p:childTnLst>
+                                </p:cTn>
+                              </p:par>
+                            </p:childTnLst>
+                          </p:cTn>
+                        </p:par>
+                      </p:childTnLst>
+                    </p:cTn>
+                  </p:par>
+                </p:childTnLst>
+              </p:cTn>
+              <p:prevCondLst>
+                <p:cond evt="onPrev" delay="0">
+                  <p:tgtEl>
+                    <p:sldTgt/>
+                  </p:tgtEl>
+                </p:cond>
+              </p:prevCondLst>
+              <p:nextCondLst>
+                <p:cond evt="onNext" delay="0">
+                  <p:tgtEl>
+                    <p:sldTgt/>
+                  </p:tgtEl>
+                </p:cond>
+              </p:nextCondLst>
+            </p:seq>
+          </p:childTnLst>
+        </p:cTn>
+      </p:par>
+    </p:tnLst>
+  </p:timing>
 </p:sld>
 </file>
 
 <file path=ppt/slides/slide10.xml><?xml version="1.0" encoding="utf-8"?>
-<p:sld xmlns:a="http://schemas.openxmlformats.org/drawingml/2006/main" xmlns:r="http://schemas.openxmlformats.org/officeDocument/2006/relationships" xmlns:p="http://schemas.openxmlformats.org/presentationml/2006/main">
+<p:sld xmlns:a="http://schemas.openxmlformats.org/drawingml/2006/main" xmlns:a16="http://schemas.microsoft.com/office/drawing/2014/main" xmlns:p="http://schemas.openxmlformats.org/presentationml/2006/main" xmlns:p14="http://schemas.microsoft.com/office/powerpoint/2010/main">
   <p:cSld>
     <p:spTree>
       <p:nvGrpSpPr>
@@ -5350,7 +5449,7 @@
           <p:cNvPr id="3" name="Title 2" descr="a9SBl91AOusIfZBRbFKiaR30fbG/UGG1Q5cXhvqJ/Odltfd2QPfFvKAUOfvjwCdQJ6YrErc/HjPYyVqaXDkWPkUXDQm7zGvS-~PF6oRPg0v3Z0xoja4cFLpQ==">
             <a:extLst>
               <a:ext uri="{FF2B5EF4-FFF2-40B4-BE49-F238E27FC236}">
-                <a16:creationId xmlns:a16="http://schemas.microsoft.com/office/drawing/2014/main" id="{2CD6E5A3-45B5-4180-8547-9BE61583C6C8}"/>
+                <a16:creationId id="{2CD6E5A3-45B5-4180-8547-9BE61583C6C8}"/>
               </a:ext>
             </a:extLst>
           </p:cNvPr>
@@ -5392,7 +5491,7 @@
           <p:cNvPr id="4" name="Subtitle 3" descr="AVtFR5FXE2BEwqViXq2s5As9WDPPqUa/SUmTlfIVEMHAJIU13Pkkbnvc6UtkK92dRhmvOvus+PaOOCx3XhL2RjBEeqrnSu6m-~Lt+WL9lY1OpeVzJ3ql6xyg==">
             <a:extLst>
               <a:ext uri="{FF2B5EF4-FFF2-40B4-BE49-F238E27FC236}">
-                <a16:creationId xmlns:a16="http://schemas.microsoft.com/office/drawing/2014/main" id="{34AEC6DA-4E55-4FBA-B896-ABA3F08CF44C}"/>
+                <a16:creationId id="{34AEC6DA-4E55-4FBA-B896-ABA3F08CF44C}"/>
               </a:ext>
             </a:extLst>
           </p:cNvPr>
@@ -5450,7 +5549,7 @@
           <p:cNvPr id="13" name="TextBox 12" descr="6/hWeP+II80DPOphKF4zdyYLWso6xC5HpsZsELcYMpan2UarcTZoHDSvXRvSeLczgNTTE2nl8NqzlzCXkK8KdOwuuP4BthC7-~1HkyrN14DXTImyix9z+mzw==">
             <a:extLst>
               <a:ext uri="{FF2B5EF4-FFF2-40B4-BE49-F238E27FC236}">
-                <a16:creationId xmlns:a16="http://schemas.microsoft.com/office/drawing/2014/main" id="{58D6D9EE-878C-4173-9F05-0816BA4FC76A}"/>
+                <a16:creationId id="{58D6D9EE-878C-4173-9F05-0816BA4FC76A}"/>
               </a:ext>
             </a:extLst>
           </p:cNvPr>
@@ -5489,7 +5588,7 @@
           <p:cNvPr id="14" name="TextBox 13" descr="2KXdkVM1/qSM7C45eh7EJhyTwUp4S/hXfWuUFxxXKLbyogHSvyuOoKVL9/bi0xacgx2NoJOH8Q4Lrcvw8/2GKQLbmbHzov1U-~lSyqnk/ooIPbw7WoB5ov0A==">
             <a:extLst>
               <a:ext uri="{FF2B5EF4-FFF2-40B4-BE49-F238E27FC236}">
-                <a16:creationId xmlns:a16="http://schemas.microsoft.com/office/drawing/2014/main" id="{76B3BC28-9DB3-4892-8A18-7BEC73174341}"/>
+                <a16:creationId id="{76B3BC28-9DB3-4892-8A18-7BEC73174341}"/>
               </a:ext>
             </a:extLst>
           </p:cNvPr>
@@ -5528,7 +5627,7 @@
           <p:cNvPr id="15" name="TextBox 14" descr="zey5u1LRE+wwvlMTO64COmJt4yOOBqQYBHovE3JoJowYAGVoymgzDrAsruY6d/om3bVH6Py10c0o6j/apO6zhIChYUYbLn2z-~m7WwrvY7iPxtPVpUaXglUw==">
             <a:extLst>
               <a:ext uri="{FF2B5EF4-FFF2-40B4-BE49-F238E27FC236}">
-                <a16:creationId xmlns:a16="http://schemas.microsoft.com/office/drawing/2014/main" id="{F4FF4C45-8126-4F77-B70D-66DB7DA12C2A}"/>
+                <a16:creationId id="{F4FF4C45-8126-4F77-B70D-66DB7DA12C2A}"/>
               </a:ext>
             </a:extLst>
           </p:cNvPr>
@@ -5567,7 +5666,7 @@
           <p:cNvPr id="16" name="TextBox 15" descr="onqiFncDFUU/MckNRHazCPlo6lXUPCNMkGa+ijKfZg/BN2vuhBWlDmajWeo794IA0JqslVP+3Kf27X8OZJYiT5aexBx7ZDZP-~uxJrHptf6derNr8BYaVfmA==">
             <a:extLst>
               <a:ext uri="{FF2B5EF4-FFF2-40B4-BE49-F238E27FC236}">
-                <a16:creationId xmlns:a16="http://schemas.microsoft.com/office/drawing/2014/main" id="{3D8865D8-C019-4CD6-A8A8-DF560757549C}"/>
+                <a16:creationId id="{3D8865D8-C019-4CD6-A8A8-DF560757549C}"/>
               </a:ext>
             </a:extLst>
           </p:cNvPr>
@@ -5606,7 +5705,7 @@
           <p:cNvPr id="21" name="Straight Connector 20" descr="q3aar5SaXNk1hg9kfXV79SFWhZiSmiESOMEEYwEYjhnO+xtgHk57YzU7SZNqFsNC1MS0MRb5pcrHfTw5jypBtmiDRcpyYGCm-~G80D49tpogNmo9XPIpC7Yw==">
             <a:extLst>
               <a:ext uri="{FF2B5EF4-FFF2-40B4-BE49-F238E27FC236}">
-                <a16:creationId xmlns:a16="http://schemas.microsoft.com/office/drawing/2014/main" id="{EDA04C70-6827-456E-8C82-B79CDD7881F4}"/>
+                <a16:creationId id="{EDA04C70-6827-456E-8C82-B79CDD7881F4}"/>
               </a:ext>
             </a:extLst>
           </p:cNvPr>
@@ -5644,21 +5743,200 @@
           </a:fontRef>
         </p:style>
       </p:cxnSp>
+      <p:sp>
+        <p:nvSpPr>
+          <p:cNvPr id="201" name="Graphic 201"/>
+          <p:cNvSpPr/>
+          <p:nvPr/>
+        </p:nvSpPr>
+        <p:spPr>
+          <a:xfrm>
+            <a:off x="2926080" y="3108960"/>
+            <a:ext cx="609600" cy="609600"/>
+          </a:xfrm>
+          <a:prstGeom prst="ellipse">
+            <a:avLst/>
+          </a:prstGeom>
+          <a:solidFill>
+            <a:srgbClr val="000000"/>
+          </a:solidFill>
+          <a:ln>
+            <a:noFill/>
+          </a:ln>
+          <a:effectLst>
+            <a:outerShdw blurRad="50800" dist="50800" dir="5400000" algn="t" rotWithShape="0">
+              <a:srgbClr val="000000">
+                <a:alpha val="40000"/>
+              </a:srgbClr>
+            </a:outerShdw>
+          </a:effectLst>
+        </p:spPr>
+        <p:txBody>
+          <a:bodyPr rtlCol="0" anchor="ctr"/>
+          <a:lstStyle/>
+          <a:p>
+            <a:pPr algn="ctr"/>
+            <a:r>
+              <a:rPr lang="en-US" sz="2400" b="1" dirty="0">
+                <a:solidFill>
+                  <a:srgbClr val="FFFFFF"/>
+                </a:solidFill>
+              </a:rPr>
+              <a:t>1</a:t>
+            </a:r>
+          </a:p>
+        </p:txBody>
+      </p:sp>
+      <p:sp>
+        <p:nvSpPr>
+          <p:cNvPr id="202" name="Graphic 202"/>
+          <p:cNvSpPr/>
+          <p:nvPr/>
+        </p:nvSpPr>
+        <p:spPr>
+          <a:xfrm>
+            <a:off x="2926080" y="5029200"/>
+            <a:ext cx="609600" cy="609600"/>
+          </a:xfrm>
+          <a:prstGeom prst="ellipse">
+            <a:avLst/>
+          </a:prstGeom>
+          <a:solidFill>
+            <a:srgbClr val="000000"/>
+          </a:solidFill>
+          <a:ln>
+            <a:noFill/>
+          </a:ln>
+          <a:effectLst>
+            <a:outerShdw blurRad="50800" dist="50800" dir="5400000" algn="t" rotWithShape="0">
+              <a:srgbClr val="000000">
+                <a:alpha val="40000"/>
+              </a:srgbClr>
+            </a:outerShdw>
+          </a:effectLst>
+        </p:spPr>
+        <p:txBody>
+          <a:bodyPr rtlCol="0" anchor="ctr"/>
+          <a:lstStyle/>
+          <a:p>
+            <a:pPr algn="ctr"/>
+            <a:r>
+              <a:rPr lang="en-US" sz="2400" b="1" dirty="0">
+                <a:solidFill>
+                  <a:srgbClr val="FFFFFF"/>
+                </a:solidFill>
+              </a:rPr>
+              <a:t>2</a:t>
+            </a:r>
+          </a:p>
+        </p:txBody>
+      </p:sp>
+      <p:sp>
+        <p:nvSpPr>
+          <p:cNvPr id="203" name="Graphic 203"/>
+          <p:cNvSpPr/>
+          <p:nvPr/>
+        </p:nvSpPr>
+        <p:spPr>
+          <a:xfrm>
+            <a:off x="8321040" y="3108960"/>
+            <a:ext cx="609600" cy="609600"/>
+          </a:xfrm>
+          <a:prstGeom prst="ellipse">
+            <a:avLst/>
+          </a:prstGeom>
+          <a:solidFill>
+            <a:srgbClr val="000000"/>
+          </a:solidFill>
+          <a:ln>
+            <a:noFill/>
+          </a:ln>
+          <a:effectLst>
+            <a:outerShdw blurRad="50800" dist="50800" dir="5400000" algn="t" rotWithShape="0">
+              <a:srgbClr val="000000">
+                <a:alpha val="40000"/>
+              </a:srgbClr>
+            </a:outerShdw>
+          </a:effectLst>
+        </p:spPr>
+        <p:txBody>
+          <a:bodyPr rtlCol="0" anchor="ctr"/>
+          <a:lstStyle/>
+          <a:p>
+            <a:pPr algn="ctr"/>
+            <a:r>
+              <a:rPr lang="en-US" sz="2400" b="1" dirty="0">
+                <a:solidFill>
+                  <a:srgbClr val="FFFFFF"/>
+                </a:solidFill>
+              </a:rPr>
+              <a:t>3</a:t>
+            </a:r>
+          </a:p>
+        </p:txBody>
+      </p:sp>
+      <p:sp>
+        <p:nvSpPr>
+          <p:cNvPr id="204" name="Graphic 204"/>
+          <p:cNvSpPr/>
+          <p:nvPr/>
+        </p:nvSpPr>
+        <p:spPr>
+          <a:xfrm>
+            <a:off x="8321040" y="5029200"/>
+            <a:ext cx="609600" cy="609600"/>
+          </a:xfrm>
+          <a:prstGeom prst="ellipse">
+            <a:avLst/>
+          </a:prstGeom>
+          <a:solidFill>
+            <a:srgbClr val="000000"/>
+          </a:solidFill>
+          <a:ln>
+            <a:noFill/>
+          </a:ln>
+          <a:effectLst>
+            <a:outerShdw blurRad="50800" dist="50800" dir="5400000" algn="t" rotWithShape="0">
+              <a:srgbClr val="000000">
+                <a:alpha val="40000"/>
+              </a:srgbClr>
+            </a:outerShdw>
+          </a:effectLst>
+        </p:spPr>
+        <p:txBody>
+          <a:bodyPr rtlCol="0" anchor="ctr"/>
+          <a:lstStyle/>
+          <a:p>
+            <a:pPr algn="ctr"/>
+            <a:r>
+              <a:rPr lang="en-US" sz="2400" b="1" dirty="0">
+                <a:solidFill>
+                  <a:srgbClr val="FFFFFF"/>
+                </a:solidFill>
+              </a:rPr>
+              <a:t>4</a:t>
+            </a:r>
+          </a:p>
+        </p:txBody>
+      </p:sp>
     </p:spTree>
     <p:extLst>
       <p:ext uri="{BB962C8B-B14F-4D97-AF65-F5344CB8AC3E}">
-        <p14:creationId xmlns:p14="http://schemas.microsoft.com/office/powerpoint/2010/main" val="3199494652"/>
+        <p14:creationId val="3199494652"/>
       </p:ext>
     </p:extLst>
   </p:cSld>
   <p:clrMapOvr>
     <a:masterClrMapping/>
   </p:clrMapOvr>
+  <p:transition>
+    <p14:cube dir="d"/>
+  </p:transition>
 </p:sld>
 </file>
 
 <file path=ppt/slides/slide2.xml><?xml version="1.0" encoding="utf-8"?>
-<p:sld xmlns:a="http://schemas.openxmlformats.org/drawingml/2006/main" xmlns:r="http://schemas.openxmlformats.org/officeDocument/2006/relationships" xmlns:p="http://schemas.openxmlformats.org/presentationml/2006/main">
+<p:sld xmlns:a="http://schemas.openxmlformats.org/drawingml/2006/main" xmlns:a14="http://schemas.microsoft.com/office/drawing/2010/main" xmlns:a16="http://schemas.microsoft.com/office/drawing/2014/main" xmlns:p="http://schemas.openxmlformats.org/presentationml/2006/main" xmlns:p14="http://schemas.microsoft.com/office/powerpoint/2010/main" xmlns:r="http://schemas.openxmlformats.org/officeDocument/2006/relationships">
   <p:cSld>
     <p:bg>
       <p:bgPr>
@@ -5687,7 +5965,7 @@
           <p:cNvPr id="2" name="Title 1" descr="wPCtRwPkPjDKU+YA0r0NJ1MNsMQHCE7fyNJhtrozJXtASsbcQ/++m5qLDXx9+Kr8YuwrhxagwGwHWY+rC3b5cm0e2vg2U0Co-~i6HZqej0eQXL2f9J2OPOsQ==">
             <a:extLst>
               <a:ext uri="{FF2B5EF4-FFF2-40B4-BE49-F238E27FC236}">
-                <a16:creationId xmlns:a16="http://schemas.microsoft.com/office/drawing/2014/main" id="{6E32CB19-CC60-4758-8E36-88BF6DFEBAE2}"/>
+                <a16:creationId id="{6E32CB19-CC60-4758-8E36-88BF6DFEBAE2}"/>
               </a:ext>
             </a:extLst>
           </p:cNvPr>
@@ -5720,15 +5998,12 @@
           <a:lstStyle/>
           <a:p>
             <a:r>
-              <a:rPr lang="en-US" sz="4800" dirty="0">
-                <a:solidFill>
-                  <a:schemeClr val="accent1">
-                    <a:lumMod val="40000"/>
-                    <a:lumOff val="60000"/>
-                  </a:schemeClr>
-                </a:solidFill>
+              <a:rPr lang="en-US" sz="6600" dirty="0" b="1">
                 <a:latin typeface="+mj-lt"/>
                 <a:cs typeface="Aharoni" panose="02010803020104030203" pitchFamily="2" charset="-79"/>
+                <a:solidFill>
+                  <a:schemeClr val="tx1"/>
+                </a:solidFill>
               </a:rPr>
               <a:t>   Contrast</a:t>
             </a:r>
@@ -5740,7 +6015,7 @@
           <p:cNvPr id="3" name="Content Placeholder 2" descr="ygPFQrNuiHmSZE93MXP0+bX55iFHh4Q0CEjCGNHXmKNmhglaRtAsWAHsLXH3tvlDsHfxUDFRXR2fI8NWAqwHMs1pIjeaB6sD-~l5VOH/XDVPUYtlcakdYBZg==">
             <a:extLst>
               <a:ext uri="{FF2B5EF4-FFF2-40B4-BE49-F238E27FC236}">
-                <a16:creationId xmlns:a16="http://schemas.microsoft.com/office/drawing/2014/main" id="{70A0772C-BE9D-43F0-8427-9FF7403CB2FF}"/>
+                <a16:creationId id="{70A0772C-BE9D-43F0-8427-9FF7403CB2FF}"/>
               </a:ext>
             </a:extLst>
           </p:cNvPr>
@@ -5828,7 +6103,7 @@
           <p:cNvPr id="6" name="Picture 5#@#g2sLYUr5RMEXzWiayrhcSbVXSy6/Ij1bNh/jzUnwbSjYtvBy+n+qhsY8wwct4WJfIXDrLYZVuHhD9fzGo6IUIH9HOSiF8aoy-~i9lm2tl4pZNyzlqS98aEUw==" descr="A picture containing food, drawing, flower&#10;&#10;Description automatically generated">
             <a:extLst>
               <a:ext uri="{FF2B5EF4-FFF2-40B4-BE49-F238E27FC236}">
-                <a16:creationId xmlns:a16="http://schemas.microsoft.com/office/drawing/2014/main" id="{CC831BF0-73F6-4F6D-8F89-7969665F821E}"/>
+                <a16:creationId id="{CC831BF0-73F6-4F6D-8F89-7969665F821E}"/>
               </a:ext>
             </a:extLst>
           </p:cNvPr>
@@ -5841,7 +6116,7 @@
           <a:blip r:embed="rId3">
             <a:extLst>
               <a:ext uri="{28A0092B-C50C-407E-A947-70E740481C1C}">
-                <a14:useLocalDpi xmlns:a14="http://schemas.microsoft.com/office/drawing/2010/main"/>
+                <a14:useLocalDpi/>
               </a:ext>
             </a:extLst>
           </a:blip>
@@ -5862,18 +6137,503 @@
     </p:spTree>
     <p:extLst>
       <p:ext uri="{BB962C8B-B14F-4D97-AF65-F5344CB8AC3E}">
-        <p14:creationId xmlns:p14="http://schemas.microsoft.com/office/powerpoint/2010/main" val="3049576765"/>
+        <p14:creationId val="3049576765"/>
       </p:ext>
     </p:extLst>
   </p:cSld>
   <p:clrMapOvr>
     <a:masterClrMapping/>
   </p:clrMapOvr>
+  <p:transition>
+    <p14:cube dir="d"/>
+  </p:transition>
+  <p:timing>
+    <p:tnLst>
+      <p:par>
+        <p:cTn id="1" dur="indefinite" restart="never" nodeType="tmRoot">
+          <p:childTnLst>
+            <p:seq concurrent="1" nextAc="seek">
+              <p:cTn id="2" dur="indefinite" nodeType="mainSeq">
+                <p:childTnLst>
+                  <p:par>
+                    <p:cTn id="3" fill="hold">
+                      <p:stCondLst>
+                        <p:cond delay="0"/>
+                      </p:stCondLst>
+                      <p:childTnLst>
+                        <p:par>
+                          <p:cTn id="4" fill="hold">
+                            <p:stCondLst>
+                              <p:cond delay="500"/>
+                            </p:stCondLst>
+                            <p:childTnLst>
+                              <p:par>
+                                <p:cTn id="5" presetID="2" presetClass="entr" presetSubtype="4" fill="hold" grpId="0" nodeType="withEffect">
+                                  <p:stCondLst>
+                                    <p:cond delay="0"/>
+                                  </p:stCondLst>
+                                  <p:childTnLst>
+                                    <p:set>
+                                      <p:cBhvr>
+                                        <p:cTn id="6" dur="1" fill="hold">
+                                          <p:stCondLst>
+                                            <p:cond delay="0"/>
+                                          </p:stCondLst>
+                                        </p:cTn>
+                                        <p:tgtEl>
+                                          <p:spTgt spid="3">
+                                            <p:txEl>
+                                              <p:pRg st="0" end="0"/>
+                                            </p:txEl>
+                                          </p:spTgt>
+                                        </p:tgtEl>
+                                        <p:attrNameLst>
+                                          <p:attrName>style.visibility</p:attrName>
+                                        </p:attrNameLst>
+                                      </p:cBhvr>
+                                      <p:to>
+                                        <p:strVal val="visible"/>
+                                      </p:to>
+                                    </p:set>
+                                    <p:anim calcmode="lin" valueType="num">
+                                      <p:cBhvr additive="base">
+                                        <p:cTn id="7" dur="750" fill="hold"/>
+                                        <p:tgtEl>
+                                          <p:spTgt spid="3">
+                                            <p:txEl>
+                                              <p:pRg st="0" end="0"/>
+                                            </p:txEl>
+                                          </p:spTgt>
+                                        </p:tgtEl>
+                                        <p:attrNameLst>
+                                          <p:attrName>ppt_x</p:attrName>
+                                        </p:attrNameLst>
+                                      </p:cBhvr>
+                                      <p:tavLst>
+                                        <p:tav tm="0">
+                                          <p:val>
+                                            <p:strVal val="#ppt_x"/>
+                                          </p:val>
+                                        </p:tav>
+                                        <p:tav tm="100000">
+                                          <p:val>
+                                            <p:strVal val="#ppt_x"/>
+                                          </p:val>
+                                        </p:tav>
+                                      </p:tavLst>
+                                    </p:anim>
+                                    <p:anim calcmode="lin" valueType="num">
+                                      <p:cBhvr additive="base">
+                                        <p:cTn id="8" dur="750" fill="hold"/>
+                                        <p:tgtEl>
+                                          <p:spTgt spid="3">
+                                            <p:txEl>
+                                              <p:pRg st="0" end="0"/>
+                                            </p:txEl>
+                                          </p:spTgt>
+                                        </p:tgtEl>
+                                        <p:attrNameLst>
+                                          <p:attrName>ppt_y</p:attrName>
+                                        </p:attrNameLst>
+                                      </p:cBhvr>
+                                      <p:tavLst>
+                                        <p:tav tm="0">
+                                          <p:val>
+                                            <p:strVal val="1+#ppt_h/2"/>
+                                          </p:val>
+                                        </p:tav>
+                                        <p:tav tm="100000">
+                                          <p:val>
+                                            <p:strVal val="#ppt_y"/>
+                                          </p:val>
+                                        </p:tav>
+                                      </p:tavLst>
+                                    </p:anim>
+                                  </p:childTnLst>
+                                </p:cTn>
+                              </p:par>
+                            </p:childTnLst>
+                          </p:cTn>
+                        </p:par>
+                      </p:childTnLst>
+                    </p:cTn>
+                  </p:par>
+                  <p:par>
+                    <p:cTn id="9" fill="hold">
+                      <p:stCondLst>
+                        <p:cond delay="0"/>
+                      </p:stCondLst>
+                      <p:childTnLst>
+                        <p:par>
+                          <p:cTn id="10" fill="hold">
+                            <p:stCondLst>
+                              <p:cond delay="500"/>
+                            </p:stCondLst>
+                            <p:childTnLst>
+                              <p:par>
+                                <p:cTn id="11" presetID="2" presetClass="entr" presetSubtype="4" fill="hold" grpId="0" nodeType="withEffect">
+                                  <p:stCondLst>
+                                    <p:cond delay="0"/>
+                                  </p:stCondLst>
+                                  <p:childTnLst>
+                                    <p:set>
+                                      <p:cBhvr>
+                                        <p:cTn id="12" dur="1" fill="hold">
+                                          <p:stCondLst>
+                                            <p:cond delay="0"/>
+                                          </p:stCondLst>
+                                        </p:cTn>
+                                        <p:tgtEl>
+                                          <p:spTgt spid="3">
+                                            <p:txEl>
+                                              <p:pRg st="1" end="1"/>
+                                            </p:txEl>
+                                          </p:spTgt>
+                                        </p:tgtEl>
+                                        <p:attrNameLst>
+                                          <p:attrName>style.visibility</p:attrName>
+                                        </p:attrNameLst>
+                                      </p:cBhvr>
+                                      <p:to>
+                                        <p:strVal val="visible"/>
+                                      </p:to>
+                                    </p:set>
+                                    <p:anim calcmode="lin" valueType="num">
+                                      <p:cBhvr additive="base">
+                                        <p:cTn id="13" dur="750" fill="hold"/>
+                                        <p:tgtEl>
+                                          <p:spTgt spid="3">
+                                            <p:txEl>
+                                              <p:pRg st="1" end="1"/>
+                                            </p:txEl>
+                                          </p:spTgt>
+                                        </p:tgtEl>
+                                        <p:attrNameLst>
+                                          <p:attrName>ppt_x</p:attrName>
+                                        </p:attrNameLst>
+                                      </p:cBhvr>
+                                      <p:tavLst>
+                                        <p:tav tm="0">
+                                          <p:val>
+                                            <p:strVal val="#ppt_x"/>
+                                          </p:val>
+                                        </p:tav>
+                                        <p:tav tm="100000">
+                                          <p:val>
+                                            <p:strVal val="#ppt_x"/>
+                                          </p:val>
+                                        </p:tav>
+                                      </p:tavLst>
+                                    </p:anim>
+                                    <p:anim calcmode="lin" valueType="num">
+                                      <p:cBhvr additive="base">
+                                        <p:cTn id="14" dur="750" fill="hold"/>
+                                        <p:tgtEl>
+                                          <p:spTgt spid="3">
+                                            <p:txEl>
+                                              <p:pRg st="1" end="1"/>
+                                            </p:txEl>
+                                          </p:spTgt>
+                                        </p:tgtEl>
+                                        <p:attrNameLst>
+                                          <p:attrName>ppt_y</p:attrName>
+                                        </p:attrNameLst>
+                                      </p:cBhvr>
+                                      <p:tavLst>
+                                        <p:tav tm="0">
+                                          <p:val>
+                                            <p:strVal val="1+#ppt_h/2"/>
+                                          </p:val>
+                                        </p:tav>
+                                        <p:tav tm="100000">
+                                          <p:val>
+                                            <p:strVal val="#ppt_y"/>
+                                          </p:val>
+                                        </p:tav>
+                                      </p:tavLst>
+                                    </p:anim>
+                                  </p:childTnLst>
+                                </p:cTn>
+                              </p:par>
+                            </p:childTnLst>
+                          </p:cTn>
+                        </p:par>
+                      </p:childTnLst>
+                    </p:cTn>
+                  </p:par>
+                  <p:par>
+                    <p:cTn id="15" fill="hold">
+                      <p:stCondLst>
+                        <p:cond delay="0"/>
+                      </p:stCondLst>
+                      <p:childTnLst>
+                        <p:par>
+                          <p:cTn id="16" fill="hold">
+                            <p:stCondLst>
+                              <p:cond delay="500"/>
+                            </p:stCondLst>
+                            <p:childTnLst>
+                              <p:par>
+                                <p:cTn id="17" presetID="2" presetClass="entr" presetSubtype="4" fill="hold" grpId="0" nodeType="withEffect">
+                                  <p:stCondLst>
+                                    <p:cond delay="0"/>
+                                  </p:stCondLst>
+                                  <p:childTnLst>
+                                    <p:set>
+                                      <p:cBhvr>
+                                        <p:cTn id="18" dur="1" fill="hold">
+                                          <p:stCondLst>
+                                            <p:cond delay="0"/>
+                                          </p:stCondLst>
+                                        </p:cTn>
+                                        <p:tgtEl>
+                                          <p:spTgt spid="3">
+                                            <p:txEl>
+                                              <p:pRg st="2" end="2"/>
+                                            </p:txEl>
+                                          </p:spTgt>
+                                        </p:tgtEl>
+                                        <p:attrNameLst>
+                                          <p:attrName>style.visibility</p:attrName>
+                                        </p:attrNameLst>
+                                      </p:cBhvr>
+                                      <p:to>
+                                        <p:strVal val="visible"/>
+                                      </p:to>
+                                    </p:set>
+                                    <p:anim calcmode="lin" valueType="num">
+                                      <p:cBhvr additive="base">
+                                        <p:cTn id="19" dur="750" fill="hold"/>
+                                        <p:tgtEl>
+                                          <p:spTgt spid="3">
+                                            <p:txEl>
+                                              <p:pRg st="2" end="2"/>
+                                            </p:txEl>
+                                          </p:spTgt>
+                                        </p:tgtEl>
+                                        <p:attrNameLst>
+                                          <p:attrName>ppt_x</p:attrName>
+                                        </p:attrNameLst>
+                                      </p:cBhvr>
+                                      <p:tavLst>
+                                        <p:tav tm="0">
+                                          <p:val>
+                                            <p:strVal val="#ppt_x"/>
+                                          </p:val>
+                                        </p:tav>
+                                        <p:tav tm="100000">
+                                          <p:val>
+                                            <p:strVal val="#ppt_x"/>
+                                          </p:val>
+                                        </p:tav>
+                                      </p:tavLst>
+                                    </p:anim>
+                                    <p:anim calcmode="lin" valueType="num">
+                                      <p:cBhvr additive="base">
+                                        <p:cTn id="20" dur="750" fill="hold"/>
+                                        <p:tgtEl>
+                                          <p:spTgt spid="3">
+                                            <p:txEl>
+                                              <p:pRg st="2" end="2"/>
+                                            </p:txEl>
+                                          </p:spTgt>
+                                        </p:tgtEl>
+                                        <p:attrNameLst>
+                                          <p:attrName>ppt_y</p:attrName>
+                                        </p:attrNameLst>
+                                      </p:cBhvr>
+                                      <p:tavLst>
+                                        <p:tav tm="0">
+                                          <p:val>
+                                            <p:strVal val="1+#ppt_h/2"/>
+                                          </p:val>
+                                        </p:tav>
+                                        <p:tav tm="100000">
+                                          <p:val>
+                                            <p:strVal val="#ppt_y"/>
+                                          </p:val>
+                                        </p:tav>
+                                      </p:tavLst>
+                                    </p:anim>
+                                  </p:childTnLst>
+                                </p:cTn>
+                              </p:par>
+                            </p:childTnLst>
+                          </p:cTn>
+                        </p:par>
+                      </p:childTnLst>
+                    </p:cTn>
+                  </p:par>
+                  <p:par>
+                    <p:cTn id="21" fill="hold">
+                      <p:stCondLst>
+                        <p:cond delay="0"/>
+                      </p:stCondLst>
+                      <p:childTnLst>
+                        <p:par>
+                          <p:cTn id="22" fill="hold">
+                            <p:stCondLst>
+                              <p:cond delay="0"/>
+                            </p:stCondLst>
+                            <p:childTnLst>
+                              <p:par>
+                                <p:cTn id="23" presetID="6" presetClass="emph" presetSubtype="32" fill="hold" grpId="1" nodeType="withEffect">
+                                  <p:stCondLst>
+                                    <p:cond delay="0"/>
+                                  </p:stCondLst>
+                                  <p:childTnLst>
+                                    <p:animScale>
+                                      <p:cBhvr>
+                                        <p:cTn id="24" dur="2000" fill="hold"/>
+                                        <p:tgtEl>
+                                          <p:spTgt spid="3">
+                                            <p:txEl>
+                                              <p:pRg st="2" end="2"/>
+                                            </p:txEl>
+                                          </p:spTgt>
+                                        </p:tgtEl>
+                                      </p:cBhvr>
+                                      <p:by x="150000" y="150000"/>
+                                    </p:animScale>
+                                  </p:childTnLst>
+                                </p:cTn>
+                              </p:par>
+                            </p:childTnLst>
+                          </p:cTn>
+                        </p:par>
+                      </p:childTnLst>
+                    </p:cTn>
+                  </p:par>
+                  <p:par>
+                    <p:cTn id="25" fill="hold">
+                      <p:stCondLst>
+                        <p:cond delay="0"/>
+                      </p:stCondLst>
+                      <p:childTnLst>
+                        <p:par>
+                          <p:cTn id="26" fill="hold">
+                            <p:stCondLst>
+                              <p:cond delay="500"/>
+                            </p:stCondLst>
+                            <p:childTnLst>
+                              <p:par>
+                                <p:cTn id="27" presetID="2" presetClass="entr" presetSubtype="4" fill="hold" grpId="0" nodeType="withEffect">
+                                  <p:stCondLst>
+                                    <p:cond delay="0"/>
+                                  </p:stCondLst>
+                                  <p:childTnLst>
+                                    <p:set>
+                                      <p:cBhvr>
+                                        <p:cTn id="28" dur="1" fill="hold">
+                                          <p:stCondLst>
+                                            <p:cond delay="0"/>
+                                          </p:stCondLst>
+                                        </p:cTn>
+                                        <p:tgtEl>
+                                          <p:spTgt spid="3">
+                                            <p:txEl>
+                                              <p:pRg st="3" end="3"/>
+                                            </p:txEl>
+                                          </p:spTgt>
+                                        </p:tgtEl>
+                                        <p:attrNameLst>
+                                          <p:attrName>style.visibility</p:attrName>
+                                        </p:attrNameLst>
+                                      </p:cBhvr>
+                                      <p:to>
+                                        <p:strVal val="visible"/>
+                                      </p:to>
+                                    </p:set>
+                                    <p:anim calcmode="lin" valueType="num">
+                                      <p:cBhvr additive="base">
+                                        <p:cTn id="29" dur="750" fill="hold"/>
+                                        <p:tgtEl>
+                                          <p:spTgt spid="3">
+                                            <p:txEl>
+                                              <p:pRg st="3" end="3"/>
+                                            </p:txEl>
+                                          </p:spTgt>
+                                        </p:tgtEl>
+                                        <p:attrNameLst>
+                                          <p:attrName>ppt_x</p:attrName>
+                                        </p:attrNameLst>
+                                      </p:cBhvr>
+                                      <p:tavLst>
+                                        <p:tav tm="0">
+                                          <p:val>
+                                            <p:strVal val="#ppt_x"/>
+                                          </p:val>
+                                        </p:tav>
+                                        <p:tav tm="100000">
+                                          <p:val>
+                                            <p:strVal val="#ppt_x"/>
+                                          </p:val>
+                                        </p:tav>
+                                      </p:tavLst>
+                                    </p:anim>
+                                    <p:anim calcmode="lin" valueType="num">
+                                      <p:cBhvr additive="base">
+                                        <p:cTn id="30" dur="750" fill="hold"/>
+                                        <p:tgtEl>
+                                          <p:spTgt spid="3">
+                                            <p:txEl>
+                                              <p:pRg st="3" end="3"/>
+                                            </p:txEl>
+                                          </p:spTgt>
+                                        </p:tgtEl>
+                                        <p:attrNameLst>
+                                          <p:attrName>ppt_y</p:attrName>
+                                        </p:attrNameLst>
+                                      </p:cBhvr>
+                                      <p:tavLst>
+                                        <p:tav tm="0">
+                                          <p:val>
+                                            <p:strVal val="1+#ppt_h/2"/>
+                                          </p:val>
+                                        </p:tav>
+                                        <p:tav tm="100000">
+                                          <p:val>
+                                            <p:strVal val="#ppt_y"/>
+                                          </p:val>
+                                        </p:tav>
+                                      </p:tavLst>
+                                    </p:anim>
+                                  </p:childTnLst>
+                                </p:cTn>
+                              </p:par>
+                            </p:childTnLst>
+                          </p:cTn>
+                        </p:par>
+                      </p:childTnLst>
+                    </p:cTn>
+                  </p:par>
+                </p:childTnLst>
+              </p:cTn>
+              <p:prevCondLst>
+                <p:cond evt="onPrev" delay="0">
+                  <p:tgtEl>
+                    <p:sldTgt/>
+                  </p:tgtEl>
+                </p:cond>
+              </p:prevCondLst>
+              <p:nextCondLst>
+                <p:cond evt="onNext" delay="0">
+                  <p:tgtEl>
+                    <p:sldTgt/>
+                  </p:tgtEl>
+                </p:cond>
+              </p:nextCondLst>
+            </p:seq>
+          </p:childTnLst>
+        </p:cTn>
+      </p:par>
+    </p:tnLst>
+  </p:timing>
 </p:sld>
 </file>
 
 <file path=ppt/slides/slide3.xml><?xml version="1.0" encoding="utf-8"?>
-<p:sld xmlns:a="http://schemas.openxmlformats.org/drawingml/2006/main" xmlns:r="http://schemas.openxmlformats.org/officeDocument/2006/relationships" xmlns:p="http://schemas.openxmlformats.org/presentationml/2006/main">
+<p:sld xmlns:a="http://schemas.openxmlformats.org/drawingml/2006/main" xmlns:p="http://schemas.openxmlformats.org/presentationml/2006/main" xmlns:p14="http://schemas.microsoft.com/office/powerpoint/2010/main">
   <p:cSld>
     <p:bg>
       <p:bgPr>
@@ -5956,21 +6716,141 @@
           </a:p>
         </p:txBody>
       </p:sp>
+      <p:sp>
+        <p:nvSpPr>
+          <p:cNvPr id="100" name="TextBox 100"/>
+          <p:cNvSpPr txBox="1"/>
+          <p:nvPr/>
+        </p:nvSpPr>
+        <p:spPr>
+          <a:xfrm>
+            <a:off x="667512" y="667512"/>
+            <a:ext cx="3200400" cy="1371600"/>
+          </a:xfrm>
+          <a:prstGeom prst="rect">
+            <a:avLst/>
+          </a:prstGeom>
+          <a:noFill/>
+        </p:spPr>
+        <p:txBody>
+          <a:bodyPr wrap="none" rtlCol="0">
+            <a:spAutoFit/>
+          </a:bodyPr>
+          <a:lstStyle/>
+          <a:p>
+            <a:r>
+              <a:rPr lang="en-US" sz="8000" dirty="0"/>
+              <a:t>Make it</a:t>
+            </a:r>
+          </a:p>
+        </p:txBody>
+      </p:sp>
+      <p:sp>
+        <p:nvSpPr>
+          <p:cNvPr id="101" name="Rectangle 101"/>
+          <p:cNvSpPr/>
+          <p:nvPr/>
+        </p:nvSpPr>
+        <p:spPr>
+          <a:xfrm>
+            <a:off x="4297680" y="365760"/>
+            <a:ext cx="3566160" cy="3566160"/>
+          </a:xfrm>
+          <a:prstGeom prst="rect">
+            <a:avLst/>
+          </a:prstGeom>
+          <a:gradFill rotWithShape="1">
+            <a:gsLst>
+              <a:gs pos="0">
+                <a:schemeClr val="accent1">
+                  <a:satMod val="103000"/>
+                  <a:lumMod val="118000"/>
+                  <a:tint val="94000"/>
+                </a:schemeClr>
+              </a:gs>
+              <a:gs pos="50000">
+                <a:schemeClr val="accent1">
+                  <a:satMod val="110000"/>
+                  <a:lumMod val="100000"/>
+                  <a:shade val="100000"/>
+                </a:schemeClr>
+              </a:gs>
+              <a:gs pos="100000">
+                <a:schemeClr val="accent1">
+                  <a:lumMod val="99000"/>
+                  <a:satMod val="120000"/>
+                  <a:shade val="78000"/>
+                </a:schemeClr>
+              </a:gs>
+            </a:gsLst>
+            <a:lin ang="5400000" scaled="0"/>
+          </a:gradFill>
+          <a:ln>
+            <a:noFill/>
+          </a:ln>
+          <a:effectLst>
+            <a:outerShdw blurRad="57150" dist="19050" dir="5400000" algn="ctr" rotWithShape="0">
+              <a:srgbClr val="000000">
+                <a:alpha val="63000"/>
+              </a:srgbClr>
+            </a:outerShdw>
+          </a:effectLst>
+          <a:scene3d>
+            <a:camera prst="orthographicFront"/>
+            <a:lightRig rig="threePt" dir="t"/>
+          </a:scene3d>
+          <a:sp3d>
+            <a:bevelT w="63500" h="25400"/>
+          </a:sp3d>
+        </p:spPr>
+        <p:style>
+          <a:lnRef idx="0">
+            <a:schemeClr val="accent1"/>
+          </a:lnRef>
+          <a:fillRef idx="3">
+            <a:schemeClr val="accent1"/>
+          </a:fillRef>
+          <a:effectRef idx="3">
+            <a:schemeClr val="accent1"/>
+          </a:effectRef>
+          <a:fontRef idx="minor">
+            <a:schemeClr val="lt1"/>
+          </a:fontRef>
+        </p:style>
+        <p:txBody>
+          <a:bodyPr rtlCol="0" anchor="ctr"/>
+          <a:lstStyle/>
+          <a:p>
+            <a:pPr algn="ctr"/>
+            <a:r>
+              <a:rPr lang="en-US" sz="16000" dirty="0">
+                <a:solidFill>
+                  <a:schemeClr val="tx1"/>
+                </a:solidFill>
+              </a:rPr>
+              <a:t>Big</a:t>
+            </a:r>
+          </a:p>
+        </p:txBody>
+      </p:sp>
     </p:spTree>
     <p:extLst>
       <p:ext uri="{BB962C8B-B14F-4D97-AF65-F5344CB8AC3E}">
-        <p14:creationId xmlns:p14="http://schemas.microsoft.com/office/powerpoint/2010/main" val="3958077147"/>
+        <p14:creationId val="3958077147"/>
       </p:ext>
     </p:extLst>
   </p:cSld>
   <p:clrMapOvr>
     <a:masterClrMapping/>
   </p:clrMapOvr>
+  <p:transition>
+    <p14:cube dir="d"/>
+  </p:transition>
 </p:sld>
 </file>
 
 <file path=ppt/slides/slide4.xml><?xml version="1.0" encoding="utf-8"?>
-<p:sld xmlns:a="http://schemas.openxmlformats.org/drawingml/2006/main" xmlns:r="http://schemas.openxmlformats.org/officeDocument/2006/relationships" xmlns:p="http://schemas.openxmlformats.org/presentationml/2006/main">
+<p:sld xmlns:a="http://schemas.openxmlformats.org/drawingml/2006/main" xmlns:a14="http://schemas.microsoft.com/office/drawing/2010/main" xmlns:a16="http://schemas.microsoft.com/office/drawing/2014/main" xmlns:p="http://schemas.openxmlformats.org/presentationml/2006/main" xmlns:p14="http://schemas.microsoft.com/office/powerpoint/2010/main" xmlns:r="http://schemas.openxmlformats.org/officeDocument/2006/relationships">
   <p:cSld>
     <p:bg>
       <p:bgPr>
@@ -5999,7 +6879,7 @@
           <p:cNvPr id="2" name="Title 1" descr="6JwTlxXInrnTD4qKgWPEk+tzcCFGRQhFbuWnFrbncxfJv0bNv+yFq/j/iVPkliySk+uVaZk0RIvelC+Q51mF34HbHAzSufQB-~yGsRyDUGoBhqmkXHxofFaQ==">
             <a:extLst>
               <a:ext uri="{FF2B5EF4-FFF2-40B4-BE49-F238E27FC236}">
-                <a16:creationId xmlns:a16="http://schemas.microsoft.com/office/drawing/2014/main" id="{6E32CB19-CC60-4758-8E36-88BF6DFEBAE2}"/>
+                <a16:creationId id="{6E32CB19-CC60-4758-8E36-88BF6DFEBAE2}"/>
               </a:ext>
             </a:extLst>
           </p:cNvPr>
@@ -6032,15 +6912,12 @@
           <a:lstStyle/>
           <a:p>
             <a:r>
-              <a:rPr lang="en-US" sz="4800" dirty="0">
-                <a:solidFill>
-                  <a:schemeClr val="accent1">
-                    <a:lumMod val="40000"/>
-                    <a:lumOff val="60000"/>
-                  </a:schemeClr>
-                </a:solidFill>
+              <a:rPr lang="en-US" sz="6600" dirty="0" b="1">
                 <a:latin typeface="+mj-lt"/>
                 <a:cs typeface="Aharoni" panose="02010803020104030203" pitchFamily="2" charset="-79"/>
+                <a:solidFill>
+                  <a:schemeClr val="tx1"/>
+                </a:solidFill>
               </a:rPr>
               <a:t>Repetition</a:t>
             </a:r>
@@ -6052,7 +6929,7 @@
           <p:cNvPr id="3" name="Content Placeholder 2" descr="iuM2wOkkuvpge1xc1SRyMZrX8vAnaLjbqtat49a7aH2yUpTeaEcHkaoRiPTyyFOVR27B/8CT/e70jBFQlGvBTySRkF+ntVxE-~jDs7GUIrYGrDwB+v7vpsFA==">
             <a:extLst>
               <a:ext uri="{FF2B5EF4-FFF2-40B4-BE49-F238E27FC236}">
-                <a16:creationId xmlns:a16="http://schemas.microsoft.com/office/drawing/2014/main" id="{70A0772C-BE9D-43F0-8427-9FF7403CB2FF}"/>
+                <a16:creationId id="{70A0772C-BE9D-43F0-8427-9FF7403CB2FF}"/>
               </a:ext>
             </a:extLst>
           </p:cNvPr>
@@ -6158,7 +7035,7 @@
           <p:cNvPr id="5" name="Picture 4#@#pBLSlBxrjYetsNyqJnxPIpQByLyQwS6c3Ti6s928DZTcqkbQjGcUv3QKhp+zYtcl6qOghbY2dkUSD9AQy4we9LhrhDy6M0cS-~BnsfXbswNzs173OVyC3S8A==" descr="A picture containing food, drawing, flower&#10;&#10;Description automatically generated">
             <a:extLst>
               <a:ext uri="{FF2B5EF4-FFF2-40B4-BE49-F238E27FC236}">
-                <a16:creationId xmlns:a16="http://schemas.microsoft.com/office/drawing/2014/main" id="{A9E6E4C1-6D3D-4E42-9734-FFBAF2FF1010}"/>
+                <a16:creationId id="{A9E6E4C1-6D3D-4E42-9734-FFBAF2FF1010}"/>
               </a:ext>
             </a:extLst>
           </p:cNvPr>
@@ -6171,7 +7048,7 @@
           <a:blip r:embed="rId3">
             <a:extLst>
               <a:ext uri="{28A0092B-C50C-407E-A947-70E740481C1C}">
-                <a14:useLocalDpi xmlns:a14="http://schemas.microsoft.com/office/drawing/2010/main"/>
+                <a14:useLocalDpi/>
               </a:ext>
             </a:extLst>
           </a:blip>
@@ -6192,18 +7069,463 @@
     </p:spTree>
     <p:extLst>
       <p:ext uri="{BB962C8B-B14F-4D97-AF65-F5344CB8AC3E}">
-        <p14:creationId xmlns:p14="http://schemas.microsoft.com/office/powerpoint/2010/main" val="2416677120"/>
+        <p14:creationId val="2416677120"/>
       </p:ext>
     </p:extLst>
   </p:cSld>
   <p:clrMapOvr>
     <a:masterClrMapping/>
   </p:clrMapOvr>
+  <p:transition>
+    <p14:cube dir="d"/>
+  </p:transition>
+  <p:timing>
+    <p:tnLst>
+      <p:par>
+        <p:cTn id="1" dur="indefinite" restart="never" nodeType="tmRoot">
+          <p:childTnLst>
+            <p:seq concurrent="1" nextAc="seek">
+              <p:cTn id="2" dur="indefinite" nodeType="mainSeq">
+                <p:childTnLst>
+                  <p:par>
+                    <p:cTn id="3" fill="hold">
+                      <p:stCondLst>
+                        <p:cond delay="0"/>
+                      </p:stCondLst>
+                      <p:childTnLst>
+                        <p:par>
+                          <p:cTn id="4" fill="hold">
+                            <p:stCondLst>
+                              <p:cond delay="500"/>
+                            </p:stCondLst>
+                            <p:childTnLst>
+                              <p:par>
+                                <p:cTn id="5" presetID="2" presetClass="entr" presetSubtype="4" fill="hold" grpId="0" nodeType="withEffect">
+                                  <p:stCondLst>
+                                    <p:cond delay="0"/>
+                                  </p:stCondLst>
+                                  <p:childTnLst>
+                                    <p:set>
+                                      <p:cBhvr>
+                                        <p:cTn id="6" dur="1" fill="hold">
+                                          <p:stCondLst>
+                                            <p:cond delay="0"/>
+                                          </p:stCondLst>
+                                        </p:cTn>
+                                        <p:tgtEl>
+                                          <p:spTgt spid="3">
+                                            <p:txEl>
+                                              <p:pRg st="0" end="0"/>
+                                            </p:txEl>
+                                          </p:spTgt>
+                                        </p:tgtEl>
+                                        <p:attrNameLst>
+                                          <p:attrName>style.visibility</p:attrName>
+                                        </p:attrNameLst>
+                                      </p:cBhvr>
+                                      <p:to>
+                                        <p:strVal val="visible"/>
+                                      </p:to>
+                                    </p:set>
+                                    <p:anim calcmode="lin" valueType="num">
+                                      <p:cBhvr additive="base">
+                                        <p:cTn id="7" dur="750" fill="hold"/>
+                                        <p:tgtEl>
+                                          <p:spTgt spid="3">
+                                            <p:txEl>
+                                              <p:pRg st="0" end="0"/>
+                                            </p:txEl>
+                                          </p:spTgt>
+                                        </p:tgtEl>
+                                        <p:attrNameLst>
+                                          <p:attrName>ppt_x</p:attrName>
+                                        </p:attrNameLst>
+                                      </p:cBhvr>
+                                      <p:tavLst>
+                                        <p:tav tm="0">
+                                          <p:val>
+                                            <p:strVal val="#ppt_x"/>
+                                          </p:val>
+                                        </p:tav>
+                                        <p:tav tm="100000">
+                                          <p:val>
+                                            <p:strVal val="#ppt_x"/>
+                                          </p:val>
+                                        </p:tav>
+                                      </p:tavLst>
+                                    </p:anim>
+                                    <p:anim calcmode="lin" valueType="num">
+                                      <p:cBhvr additive="base">
+                                        <p:cTn id="8" dur="750" fill="hold"/>
+                                        <p:tgtEl>
+                                          <p:spTgt spid="3">
+                                            <p:txEl>
+                                              <p:pRg st="0" end="0"/>
+                                            </p:txEl>
+                                          </p:spTgt>
+                                        </p:tgtEl>
+                                        <p:attrNameLst>
+                                          <p:attrName>ppt_y</p:attrName>
+                                        </p:attrNameLst>
+                                      </p:cBhvr>
+                                      <p:tavLst>
+                                        <p:tav tm="0">
+                                          <p:val>
+                                            <p:strVal val="1+#ppt_h/2"/>
+                                          </p:val>
+                                        </p:tav>
+                                        <p:tav tm="100000">
+                                          <p:val>
+                                            <p:strVal val="#ppt_y"/>
+                                          </p:val>
+                                        </p:tav>
+                                      </p:tavLst>
+                                    </p:anim>
+                                  </p:childTnLst>
+                                </p:cTn>
+                              </p:par>
+                            </p:childTnLst>
+                          </p:cTn>
+                        </p:par>
+                      </p:childTnLst>
+                    </p:cTn>
+                  </p:par>
+                  <p:par>
+                    <p:cTn id="9" fill="hold">
+                      <p:stCondLst>
+                        <p:cond delay="0"/>
+                      </p:stCondLst>
+                      <p:childTnLst>
+                        <p:par>
+                          <p:cTn id="10" fill="hold">
+                            <p:stCondLst>
+                              <p:cond delay="500"/>
+                            </p:stCondLst>
+                            <p:childTnLst>
+                              <p:par>
+                                <p:cTn id="11" presetID="2" presetClass="entr" presetSubtype="4" fill="hold" grpId="0" nodeType="withEffect">
+                                  <p:stCondLst>
+                                    <p:cond delay="0"/>
+                                  </p:stCondLst>
+                                  <p:childTnLst>
+                                    <p:set>
+                                      <p:cBhvr>
+                                        <p:cTn id="12" dur="1" fill="hold">
+                                          <p:stCondLst>
+                                            <p:cond delay="0"/>
+                                          </p:stCondLst>
+                                        </p:cTn>
+                                        <p:tgtEl>
+                                          <p:spTgt spid="3">
+                                            <p:txEl>
+                                              <p:pRg st="1" end="1"/>
+                                            </p:txEl>
+                                          </p:spTgt>
+                                        </p:tgtEl>
+                                        <p:attrNameLst>
+                                          <p:attrName>style.visibility</p:attrName>
+                                        </p:attrNameLst>
+                                      </p:cBhvr>
+                                      <p:to>
+                                        <p:strVal val="visible"/>
+                                      </p:to>
+                                    </p:set>
+                                    <p:anim calcmode="lin" valueType="num">
+                                      <p:cBhvr additive="base">
+                                        <p:cTn id="13" dur="750" fill="hold"/>
+                                        <p:tgtEl>
+                                          <p:spTgt spid="3">
+                                            <p:txEl>
+                                              <p:pRg st="1" end="1"/>
+                                            </p:txEl>
+                                          </p:spTgt>
+                                        </p:tgtEl>
+                                        <p:attrNameLst>
+                                          <p:attrName>ppt_x</p:attrName>
+                                        </p:attrNameLst>
+                                      </p:cBhvr>
+                                      <p:tavLst>
+                                        <p:tav tm="0">
+                                          <p:val>
+                                            <p:strVal val="#ppt_x"/>
+                                          </p:val>
+                                        </p:tav>
+                                        <p:tav tm="100000">
+                                          <p:val>
+                                            <p:strVal val="#ppt_x"/>
+                                          </p:val>
+                                        </p:tav>
+                                      </p:tavLst>
+                                    </p:anim>
+                                    <p:anim calcmode="lin" valueType="num">
+                                      <p:cBhvr additive="base">
+                                        <p:cTn id="14" dur="750" fill="hold"/>
+                                        <p:tgtEl>
+                                          <p:spTgt spid="3">
+                                            <p:txEl>
+                                              <p:pRg st="1" end="1"/>
+                                            </p:txEl>
+                                          </p:spTgt>
+                                        </p:tgtEl>
+                                        <p:attrNameLst>
+                                          <p:attrName>ppt_y</p:attrName>
+                                        </p:attrNameLst>
+                                      </p:cBhvr>
+                                      <p:tavLst>
+                                        <p:tav tm="0">
+                                          <p:val>
+                                            <p:strVal val="1+#ppt_h/2"/>
+                                          </p:val>
+                                        </p:tav>
+                                        <p:tav tm="100000">
+                                          <p:val>
+                                            <p:strVal val="#ppt_y"/>
+                                          </p:val>
+                                        </p:tav>
+                                      </p:tavLst>
+                                    </p:anim>
+                                  </p:childTnLst>
+                                </p:cTn>
+                              </p:par>
+                            </p:childTnLst>
+                          </p:cTn>
+                        </p:par>
+                      </p:childTnLst>
+                    </p:cTn>
+                  </p:par>
+                  <p:par>
+                    <p:cTn id="15" fill="hold">
+                      <p:stCondLst>
+                        <p:cond delay="0"/>
+                      </p:stCondLst>
+                      <p:childTnLst>
+                        <p:par>
+                          <p:cTn id="16" fill="hold">
+                            <p:stCondLst>
+                              <p:cond delay="500"/>
+                            </p:stCondLst>
+                            <p:childTnLst>
+                              <p:par>
+                                <p:cTn id="17" presetID="2" presetClass="entr" presetSubtype="4" fill="hold" grpId="0" nodeType="withEffect">
+                                  <p:stCondLst>
+                                    <p:cond delay="0"/>
+                                  </p:stCondLst>
+                                  <p:childTnLst>
+                                    <p:set>
+                                      <p:cBhvr>
+                                        <p:cTn id="18" dur="1" fill="hold">
+                                          <p:stCondLst>
+                                            <p:cond delay="0"/>
+                                          </p:stCondLst>
+                                        </p:cTn>
+                                        <p:tgtEl>
+                                          <p:spTgt spid="3">
+                                            <p:txEl>
+                                              <p:pRg st="2" end="2"/>
+                                            </p:txEl>
+                                          </p:spTgt>
+                                        </p:tgtEl>
+                                        <p:attrNameLst>
+                                          <p:attrName>style.visibility</p:attrName>
+                                        </p:attrNameLst>
+                                      </p:cBhvr>
+                                      <p:to>
+                                        <p:strVal val="visible"/>
+                                      </p:to>
+                                    </p:set>
+                                    <p:anim calcmode="lin" valueType="num">
+                                      <p:cBhvr additive="base">
+                                        <p:cTn id="19" dur="750" fill="hold"/>
+                                        <p:tgtEl>
+                                          <p:spTgt spid="3">
+                                            <p:txEl>
+                                              <p:pRg st="2" end="2"/>
+                                            </p:txEl>
+                                          </p:spTgt>
+                                        </p:tgtEl>
+                                        <p:attrNameLst>
+                                          <p:attrName>ppt_x</p:attrName>
+                                        </p:attrNameLst>
+                                      </p:cBhvr>
+                                      <p:tavLst>
+                                        <p:tav tm="0">
+                                          <p:val>
+                                            <p:strVal val="#ppt_x"/>
+                                          </p:val>
+                                        </p:tav>
+                                        <p:tav tm="100000">
+                                          <p:val>
+                                            <p:strVal val="#ppt_x"/>
+                                          </p:val>
+                                        </p:tav>
+                                      </p:tavLst>
+                                    </p:anim>
+                                    <p:anim calcmode="lin" valueType="num">
+                                      <p:cBhvr additive="base">
+                                        <p:cTn id="20" dur="750" fill="hold"/>
+                                        <p:tgtEl>
+                                          <p:spTgt spid="3">
+                                            <p:txEl>
+                                              <p:pRg st="2" end="2"/>
+                                            </p:txEl>
+                                          </p:spTgt>
+                                        </p:tgtEl>
+                                        <p:attrNameLst>
+                                          <p:attrName>ppt_y</p:attrName>
+                                        </p:attrNameLst>
+                                      </p:cBhvr>
+                                      <p:tavLst>
+                                        <p:tav tm="0">
+                                          <p:val>
+                                            <p:strVal val="1+#ppt_h/2"/>
+                                          </p:val>
+                                        </p:tav>
+                                        <p:tav tm="100000">
+                                          <p:val>
+                                            <p:strVal val="#ppt_y"/>
+                                          </p:val>
+                                        </p:tav>
+                                      </p:tavLst>
+                                    </p:anim>
+                                  </p:childTnLst>
+                                </p:cTn>
+                              </p:par>
+                            </p:childTnLst>
+                          </p:cTn>
+                        </p:par>
+                      </p:childTnLst>
+                    </p:cTn>
+                  </p:par>
+                  <p:par>
+                    <p:cTn id="21" fill="hold">
+                      <p:stCondLst>
+                        <p:cond delay="0"/>
+                      </p:stCondLst>
+                      <p:childTnLst>
+                        <p:par>
+                          <p:cTn id="22" fill="hold">
+                            <p:stCondLst>
+                              <p:cond delay="500"/>
+                            </p:stCondLst>
+                            <p:childTnLst>
+                              <p:par>
+                                <p:cTn id="23" presetID="2" presetClass="entr" presetSubtype="4" fill="hold" grpId="0" nodeType="withEffect">
+                                  <p:stCondLst>
+                                    <p:cond delay="0"/>
+                                  </p:stCondLst>
+                                  <p:childTnLst>
+                                    <p:set>
+                                      <p:cBhvr>
+                                        <p:cTn id="24" dur="1" fill="hold">
+                                          <p:stCondLst>
+                                            <p:cond delay="0"/>
+                                          </p:stCondLst>
+                                        </p:cTn>
+                                        <p:tgtEl>
+                                          <p:spTgt spid="3">
+                                            <p:txEl>
+                                              <p:pRg st="3" end="3"/>
+                                            </p:txEl>
+                                          </p:spTgt>
+                                        </p:tgtEl>
+                                        <p:attrNameLst>
+                                          <p:attrName>style.visibility</p:attrName>
+                                        </p:attrNameLst>
+                                      </p:cBhvr>
+                                      <p:to>
+                                        <p:strVal val="visible"/>
+                                      </p:to>
+                                    </p:set>
+                                    <p:anim calcmode="lin" valueType="num">
+                                      <p:cBhvr additive="base">
+                                        <p:cTn id="25" dur="750" fill="hold"/>
+                                        <p:tgtEl>
+                                          <p:spTgt spid="3">
+                                            <p:txEl>
+                                              <p:pRg st="3" end="3"/>
+                                            </p:txEl>
+                                          </p:spTgt>
+                                        </p:tgtEl>
+                                        <p:attrNameLst>
+                                          <p:attrName>ppt_x</p:attrName>
+                                        </p:attrNameLst>
+                                      </p:cBhvr>
+                                      <p:tavLst>
+                                        <p:tav tm="0">
+                                          <p:val>
+                                            <p:strVal val="#ppt_x"/>
+                                          </p:val>
+                                        </p:tav>
+                                        <p:tav tm="100000">
+                                          <p:val>
+                                            <p:strVal val="#ppt_x"/>
+                                          </p:val>
+                                        </p:tav>
+                                      </p:tavLst>
+                                    </p:anim>
+                                    <p:anim calcmode="lin" valueType="num">
+                                      <p:cBhvr additive="base">
+                                        <p:cTn id="26" dur="750" fill="hold"/>
+                                        <p:tgtEl>
+                                          <p:spTgt spid="3">
+                                            <p:txEl>
+                                              <p:pRg st="3" end="3"/>
+                                            </p:txEl>
+                                          </p:spTgt>
+                                        </p:tgtEl>
+                                        <p:attrNameLst>
+                                          <p:attrName>ppt_y</p:attrName>
+                                        </p:attrNameLst>
+                                      </p:cBhvr>
+                                      <p:tavLst>
+                                        <p:tav tm="0">
+                                          <p:val>
+                                            <p:strVal val="1+#ppt_h/2"/>
+                                          </p:val>
+                                        </p:tav>
+                                        <p:tav tm="100000">
+                                          <p:val>
+                                            <p:strVal val="#ppt_y"/>
+                                          </p:val>
+                                        </p:tav>
+                                      </p:tavLst>
+                                    </p:anim>
+                                  </p:childTnLst>
+                                </p:cTn>
+                              </p:par>
+                            </p:childTnLst>
+                          </p:cTn>
+                        </p:par>
+                      </p:childTnLst>
+                    </p:cTn>
+                  </p:par>
+                </p:childTnLst>
+              </p:cTn>
+              <p:prevCondLst>
+                <p:cond evt="onPrev" delay="0">
+                  <p:tgtEl>
+                    <p:sldTgt/>
+                  </p:tgtEl>
+                </p:cond>
+              </p:prevCondLst>
+              <p:nextCondLst>
+                <p:cond evt="onNext" delay="0">
+                  <p:tgtEl>
+                    <p:sldTgt/>
+                  </p:tgtEl>
+                </p:cond>
+              </p:nextCondLst>
+            </p:seq>
+          </p:childTnLst>
+        </p:cTn>
+      </p:par>
+    </p:tnLst>
+  </p:timing>
 </p:sld>
 </file>
 
 <file path=ppt/slides/slide5.xml><?xml version="1.0" encoding="utf-8"?>
-<p:sld xmlns:a="http://schemas.openxmlformats.org/drawingml/2006/main" xmlns:r="http://schemas.openxmlformats.org/officeDocument/2006/relationships" xmlns:p="http://schemas.openxmlformats.org/presentationml/2006/main">
+<p:sld xmlns:a="http://schemas.openxmlformats.org/drawingml/2006/main" xmlns:a14="http://schemas.microsoft.com/office/drawing/2010/main" xmlns:a16="http://schemas.microsoft.com/office/drawing/2014/main" xmlns:p="http://schemas.openxmlformats.org/presentationml/2006/main" xmlns:p14="http://schemas.microsoft.com/office/powerpoint/2010/main" xmlns:r="http://schemas.openxmlformats.org/officeDocument/2006/relationships">
   <p:cSld>
     <p:bg>
       <p:bgPr>
@@ -6232,7 +7554,7 @@
           <p:cNvPr id="10" name="Picture 9#@#f6HXTkdqUhrpEhg68p0mkHzwzRq3NyU39jB+83/ZCT58gPwTJoSJoXv1X9vLJdJkLaH2LzJCdQO3S3p4FTKGkufi2K8aeFck-~qz4Ca51YeUt+udYXNh4gnQ==" descr="A picture containing food, drawing, flower&#10;&#10;Description automatically generated">
             <a:extLst>
               <a:ext uri="{FF2B5EF4-FFF2-40B4-BE49-F238E27FC236}">
-                <a16:creationId xmlns:a16="http://schemas.microsoft.com/office/drawing/2014/main" id="{4386B3A0-3906-4955-BB07-C5CE7C5B2A1B}"/>
+                <a16:creationId id="{4386B3A0-3906-4955-BB07-C5CE7C5B2A1B}"/>
               </a:ext>
             </a:extLst>
           </p:cNvPr>
@@ -6245,7 +7567,7 @@
           <a:blip r:embed="rId3">
             <a:extLst>
               <a:ext uri="{28A0092B-C50C-407E-A947-70E740481C1C}">
-                <a14:useLocalDpi xmlns:a14="http://schemas.microsoft.com/office/drawing/2010/main"/>
+                <a14:useLocalDpi/>
               </a:ext>
             </a:extLst>
           </a:blip>
@@ -6261,6 +7583,19 @@
           <a:prstGeom prst="rect">
             <a:avLst/>
           </a:prstGeom>
+          <a:ln>
+            <a:noFill/>
+          </a:ln>
+          <a:effectLst>
+            <a:reflection blurRad="12700" stA="48000" endA="300" endPos="55000" dist="50800" dir="5400000" sy="-100000" algn="bl" rotWithShape="0"/>
+          </a:effectLst>
+          <a:scene3d>
+            <a:camera prst="perspectiveRight"/>
+            <a:lightRig rig="balanced" dir="t"/>
+          </a:scene3d>
+          <a:sp3d>
+            <a:bevelT w="190500" h="38100"/>
+          </a:sp3d>
         </p:spPr>
       </p:pic>
       <p:sp>
@@ -6268,7 +7603,7 @@
           <p:cNvPr id="2" name="Title 1" descr="YlqoTjriUEqBr6USeuA3gz1H1WtKbydxRaw81qiXb3gmyF3R27KYtfszkwznu+mCfydPT7gNC0klh/qfKbmxnhY3J5ohTwRX-~ldagOspX81EhJpL/ZLHfug==">
             <a:extLst>
               <a:ext uri="{FF2B5EF4-FFF2-40B4-BE49-F238E27FC236}">
-                <a16:creationId xmlns:a16="http://schemas.microsoft.com/office/drawing/2014/main" id="{6E32CB19-CC60-4758-8E36-88BF6DFEBAE2}"/>
+                <a16:creationId id="{6E32CB19-CC60-4758-8E36-88BF6DFEBAE2}"/>
               </a:ext>
             </a:extLst>
           </p:cNvPr>
@@ -6325,7 +7660,7 @@
           <p:cNvPr id="4" name="Picture 3#@#m+D5zbNkYOUV6KmoFNkmI90nIp6o2FkT5J+7X+IYZpGKBArG5aYbUc1lybC/DEsSXNfS5FtFu5jyow7qPuO7JdKjlMt9bgHZ-~eEXjbqSgaWFAq/lzDP0UIg==" descr="">
             <a:extLst>
               <a:ext uri="{FF2B5EF4-FFF2-40B4-BE49-F238E27FC236}">
-                <a16:creationId xmlns:a16="http://schemas.microsoft.com/office/drawing/2014/main" id="{F0E915A9-2C32-4935-B790-55028BDB6873}"/>
+                <a16:creationId id="{F0E915A9-2C32-4935-B790-55028BDB6873}"/>
               </a:ext>
             </a:extLst>
           </p:cNvPr>
@@ -6339,7 +7674,7 @@
             <a:grayscl/>
             <a:extLst>
               <a:ext uri="{28A0092B-C50C-407E-A947-70E740481C1C}">
-                <a14:useLocalDpi xmlns:a14="http://schemas.microsoft.com/office/drawing/2010/main"/>
+                <a14:useLocalDpi/>
               </a:ext>
             </a:extLst>
           </a:blip>
@@ -6351,34 +7686,21 @@
             <a:off x="3525467" y="2812727"/>
             <a:ext cx="4567718" cy="3446753"/>
           </a:xfrm>
-          <a:prstGeom prst="roundRect">
-            <a:avLst>
-              <a:gd name="adj" fmla="val 4167"/>
-            </a:avLst>
+          <a:prstGeom prst="rect">
+            <a:avLst/>
           </a:prstGeom>
-          <a:solidFill>
-            <a:srgbClr val="FFFFFF"/>
-          </a:solidFill>
-          <a:ln w="76200" cap="sq">
-            <a:solidFill>
-              <a:srgbClr val="EAEAEA"/>
-            </a:solidFill>
-            <a:miter lim="800000"/>
+          <a:ln>
+            <a:noFill/>
           </a:ln>
           <a:effectLst>
-            <a:reflection blurRad="12700" stA="33000" endPos="28000" dist="5000" dir="5400000" sy="-100000" algn="bl" rotWithShape="0"/>
+            <a:reflection blurRad="12700" stA="48000" endA="300" endPos="55000" dist="50800" dir="5400000" sy="-100000" algn="bl" rotWithShape="0"/>
           </a:effectLst>
           <a:scene3d>
-            <a:camera prst="orthographicFront"/>
-            <a:lightRig rig="threePt" dir="t">
-              <a:rot lat="0" lon="0" rev="2700000"/>
-            </a:lightRig>
+            <a:camera prst="perspectiveRight"/>
+            <a:lightRig rig="balanced" dir="t"/>
           </a:scene3d>
-          <a:sp3d contourW="6350">
-            <a:bevelT h="38100"/>
-            <a:contourClr>
-              <a:srgbClr val="C0C0C0"/>
-            </a:contourClr>
+          <a:sp3d>
+            <a:bevelT w="190500" h="38100"/>
           </a:sp3d>
         </p:spPr>
       </p:pic>
@@ -6387,7 +7709,7 @@
           <p:cNvPr id="6" name="Picture 5#@#Rg2LJA5Uolf1cSS7oK6s0kwkPO2jMPlHtCNSqe/eHSyVClFzeMhkIfQJck+cWgFDU+DGrOHy8Lm5IWqwWmp7fZBKtn0f0xVt-~zzwhaQqC51bpDgqzXHmjFg==" descr="">
             <a:extLst>
               <a:ext uri="{FF2B5EF4-FFF2-40B4-BE49-F238E27FC236}">
-                <a16:creationId xmlns:a16="http://schemas.microsoft.com/office/drawing/2014/main" id="{5DABDDE7-01C7-489D-B850-0A9589314654}"/>
+                <a16:creationId id="{5DABDDE7-01C7-489D-B850-0A9589314654}"/>
               </a:ext>
             </a:extLst>
           </p:cNvPr>
@@ -6401,7 +7723,7 @@
             <a:grayscl/>
             <a:extLst>
               <a:ext uri="{28A0092B-C50C-407E-A947-70E740481C1C}">
-                <a14:useLocalDpi xmlns:a14="http://schemas.microsoft.com/office/drawing/2010/main"/>
+                <a14:useLocalDpi/>
               </a:ext>
             </a:extLst>
           </a:blip>
@@ -6413,32 +7735,21 @@
             <a:off x="1" y="2812728"/>
             <a:ext cx="3387256" cy="3446753"/>
           </a:xfrm>
-          <a:prstGeom prst="ellipse">
+          <a:prstGeom prst="rect">
             <a:avLst/>
           </a:prstGeom>
-          <a:ln w="63500" cap="rnd">
-            <a:solidFill>
-              <a:srgbClr val="333333"/>
-            </a:solidFill>
+          <a:ln>
+            <a:noFill/>
           </a:ln>
           <a:effectLst>
-            <a:outerShdw blurRad="381000" dist="292100" dir="5400000" sx="-80000" sy="-18000" rotWithShape="0">
-              <a:srgbClr val="000000">
-                <a:alpha val="22000"/>
-              </a:srgbClr>
-            </a:outerShdw>
+            <a:reflection blurRad="12700" stA="48000" endA="300" endPos="55000" dist="50800" dir="5400000" sy="-100000" algn="bl" rotWithShape="0"/>
           </a:effectLst>
           <a:scene3d>
-            <a:camera prst="orthographicFront"/>
-            <a:lightRig rig="contrasting" dir="t">
-              <a:rot lat="0" lon="0" rev="3000000"/>
-            </a:lightRig>
+            <a:camera prst="perspectiveRight"/>
+            <a:lightRig rig="balanced" dir="t"/>
           </a:scene3d>
-          <a:sp3d contourW="7620">
-            <a:bevelT w="95250" h="31750"/>
-            <a:contourClr>
-              <a:srgbClr val="333333"/>
-            </a:contourClr>
+          <a:sp3d>
+            <a:bevelT w="190500" h="38100"/>
           </a:sp3d>
         </p:spPr>
       </p:pic>
@@ -6447,7 +7758,7 @@
           <p:cNvPr id="8" name="Picture 7#@#ftV0KntzyA67g6E941IlSwetaP39+wb/rCydK4jgCkorXLiDk5egwhSwA9QVBgjP41VzzHCGYdSa6xU+f5AGxSz7GX0yDqka-~eVv9I7Kmfc+1QHdgNr+JLw==" descr="">
             <a:extLst>
               <a:ext uri="{FF2B5EF4-FFF2-40B4-BE49-F238E27FC236}">
-                <a16:creationId xmlns:a16="http://schemas.microsoft.com/office/drawing/2014/main" id="{674E4B10-BBAF-4998-84BF-136A1D41159D}"/>
+                <a16:creationId id="{674E4B10-BBAF-4998-84BF-136A1D41159D}"/>
               </a:ext>
             </a:extLst>
           </p:cNvPr>
@@ -6461,7 +7772,7 @@
             <a:grayscl/>
             <a:extLst>
               <a:ext uri="{28A0092B-C50C-407E-A947-70E740481C1C}">
-                <a14:useLocalDpi xmlns:a14="http://schemas.microsoft.com/office/drawing/2010/main"/>
+                <a14:useLocalDpi/>
               </a:ext>
             </a:extLst>
           </a:blip>
@@ -6473,32 +7784,21 @@
             <a:off x="8231395" y="2807973"/>
             <a:ext cx="3884254" cy="3446753"/>
           </a:xfrm>
-          <a:prstGeom prst="roundRect">
-            <a:avLst>
-              <a:gd name="adj" fmla="val 16667"/>
-            </a:avLst>
+          <a:prstGeom prst="rect">
+            <a:avLst/>
           </a:prstGeom>
           <a:ln>
             <a:noFill/>
           </a:ln>
           <a:effectLst>
-            <a:outerShdw blurRad="76200" dist="38100" dir="7800000" algn="tl" rotWithShape="0">
-              <a:srgbClr val="000000">
-                <a:alpha val="40000"/>
-              </a:srgbClr>
-            </a:outerShdw>
+            <a:reflection blurRad="12700" stA="48000" endA="300" endPos="55000" dist="50800" dir="5400000" sy="-100000" algn="bl" rotWithShape="0"/>
           </a:effectLst>
           <a:scene3d>
-            <a:camera prst="orthographicFront"/>
-            <a:lightRig rig="contrasting" dir="t">
-              <a:rot lat="0" lon="0" rev="4200000"/>
-            </a:lightRig>
+            <a:camera prst="perspectiveRight"/>
+            <a:lightRig rig="balanced" dir="t"/>
           </a:scene3d>
-          <a:sp3d prstMaterial="plastic">
-            <a:bevelT w="381000" h="114300" prst="relaxedInset"/>
-            <a:contourClr>
-              <a:srgbClr val="969696"/>
-            </a:contourClr>
+          <a:sp3d>
+            <a:bevelT w="190500" h="38100"/>
           </a:sp3d>
         </p:spPr>
       </p:pic>
@@ -6507,7 +7807,7 @@
           <p:cNvPr id="11" name="Picture 10#@#JdXxoQqxbEVFlL2VssOSv4ersMUFKHYgMhRMyJb7hfwXz7PjTHFjX3tmCpwphfqyWnWFjieKD+rIUKBIRn/klEHpk1iNWelL-~uIetjYM9A0uUensQlWj8Sg==" descr="A picture containing food, drawing, flower&#10;&#10;Description automatically generated">
             <a:extLst>
               <a:ext uri="{FF2B5EF4-FFF2-40B4-BE49-F238E27FC236}">
-                <a16:creationId xmlns:a16="http://schemas.microsoft.com/office/drawing/2014/main" id="{881BF913-7F4F-4AE7-85A8-11E656E8A4F5}"/>
+                <a16:creationId id="{881BF913-7F4F-4AE7-85A8-11E656E8A4F5}"/>
               </a:ext>
             </a:extLst>
           </p:cNvPr>
@@ -6520,7 +7820,7 @@
           <a:blip r:embed="rId3">
             <a:extLst>
               <a:ext uri="{28A0092B-C50C-407E-A947-70E740481C1C}">
-                <a14:useLocalDpi xmlns:a14="http://schemas.microsoft.com/office/drawing/2010/main"/>
+                <a14:useLocalDpi/>
               </a:ext>
             </a:extLst>
           </a:blip>
@@ -6541,18 +7841,21 @@
     </p:spTree>
     <p:extLst>
       <p:ext uri="{BB962C8B-B14F-4D97-AF65-F5344CB8AC3E}">
-        <p14:creationId xmlns:p14="http://schemas.microsoft.com/office/powerpoint/2010/main" val="65608884"/>
+        <p14:creationId val="65608884"/>
       </p:ext>
     </p:extLst>
   </p:cSld>
   <p:clrMapOvr>
     <a:masterClrMapping/>
   </p:clrMapOvr>
+  <p:transition>
+    <p14:cube dir="d"/>
+  </p:transition>
 </p:sld>
 </file>
 
 <file path=ppt/slides/slide6.xml><?xml version="1.0" encoding="utf-8"?>
-<p:sld xmlns:a="http://schemas.openxmlformats.org/drawingml/2006/main" xmlns:r="http://schemas.openxmlformats.org/officeDocument/2006/relationships" xmlns:p="http://schemas.openxmlformats.org/presentationml/2006/main">
+<p:sld xmlns:a="http://schemas.openxmlformats.org/drawingml/2006/main" xmlns:a14="http://schemas.microsoft.com/office/drawing/2010/main" xmlns:a16="http://schemas.microsoft.com/office/drawing/2014/main" xmlns:p="http://schemas.openxmlformats.org/presentationml/2006/main" xmlns:p14="http://schemas.microsoft.com/office/powerpoint/2010/main" xmlns:r="http://schemas.openxmlformats.org/officeDocument/2006/relationships">
   <p:cSld>
     <p:bg>
       <p:bgPr>
@@ -6581,7 +7884,7 @@
           <p:cNvPr id="2" name="Title 1" descr="wS+bY3lOAonikA0fv0D652Sk+z10K7jLrFqej8cixbsjtKeH+F2fwpOXlTaIH5b2kWMXMHtDEUMOklCP2T9XyoRXCb5InBW2-~rhXBlm6jyzFjLUNuG73MNw==">
             <a:extLst>
               <a:ext uri="{FF2B5EF4-FFF2-40B4-BE49-F238E27FC236}">
-                <a16:creationId xmlns:a16="http://schemas.microsoft.com/office/drawing/2014/main" id="{6E32CB19-CC60-4758-8E36-88BF6DFEBAE2}"/>
+                <a16:creationId id="{6E32CB19-CC60-4758-8E36-88BF6DFEBAE2}"/>
               </a:ext>
             </a:extLst>
           </p:cNvPr>
@@ -6619,15 +7922,12 @@
           <a:lstStyle/>
           <a:p>
             <a:r>
-              <a:rPr lang="en-US" sz="4800" dirty="0">
-                <a:solidFill>
-                  <a:schemeClr val="accent1">
-                    <a:lumMod val="40000"/>
-                    <a:lumOff val="60000"/>
-                  </a:schemeClr>
-                </a:solidFill>
+              <a:rPr lang="en-US" sz="6600" dirty="0" b="1">
                 <a:latin typeface="+mj-lt"/>
                 <a:cs typeface="Aharoni" panose="02010803020104030203" pitchFamily="2" charset="-79"/>
+                <a:solidFill>
+                  <a:schemeClr val="tx1"/>
+                </a:solidFill>
               </a:rPr>
               <a:t>Alignment</a:t>
             </a:r>
@@ -6639,7 +7939,7 @@
           <p:cNvPr id="3" name="Content Placeholder 2" descr="JkFaBmJT+tQkCpjDt5RExQCZQu5ml3J521ZgI5D/BLtEP4w3vkTzSBGIBtuh8AeFdnnteg7g11W1c16/4UVN3vibSWAggmYm-~lIqvcWVTmKQFsI1q2MjGsA==">
             <a:extLst>
               <a:ext uri="{FF2B5EF4-FFF2-40B4-BE49-F238E27FC236}">
-                <a16:creationId xmlns:a16="http://schemas.microsoft.com/office/drawing/2014/main" id="{70A0772C-BE9D-43F0-8427-9FF7403CB2FF}"/>
+                <a16:creationId id="{70A0772C-BE9D-43F0-8427-9FF7403CB2FF}"/>
               </a:ext>
             </a:extLst>
           </p:cNvPr>
@@ -6754,7 +8054,7 @@
           <p:cNvPr id="6" name="Picture 5#@#r/CphzZJOm+WiEkCGDJjvrXia4g19J0CLkcAWISN+ZBwpaQ1S4lbG+1vzHI30OtHm0m6XtiwzaiClksdDTHPhG0jxlHT74bE-~Zzaj07gbaQLZFw5nAhlkgA==" descr="A picture containing food, drawing, flower&#10;&#10;Description automatically generated">
             <a:extLst>
               <a:ext uri="{FF2B5EF4-FFF2-40B4-BE49-F238E27FC236}">
-                <a16:creationId xmlns:a16="http://schemas.microsoft.com/office/drawing/2014/main" id="{BF5384B6-7751-4372-B262-E70C54CAA792}"/>
+                <a16:creationId id="{BF5384B6-7751-4372-B262-E70C54CAA792}"/>
               </a:ext>
             </a:extLst>
           </p:cNvPr>
@@ -6767,7 +8067,7 @@
           <a:blip r:embed="rId3">
             <a:extLst>
               <a:ext uri="{28A0092B-C50C-407E-A947-70E740481C1C}">
-                <a14:useLocalDpi xmlns:a14="http://schemas.microsoft.com/office/drawing/2010/main"/>
+                <a14:useLocalDpi/>
               </a:ext>
             </a:extLst>
           </a:blip>
@@ -6788,18 +8088,463 @@
     </p:spTree>
     <p:extLst>
       <p:ext uri="{BB962C8B-B14F-4D97-AF65-F5344CB8AC3E}">
-        <p14:creationId xmlns:p14="http://schemas.microsoft.com/office/powerpoint/2010/main" val="327090855"/>
+        <p14:creationId val="327090855"/>
       </p:ext>
     </p:extLst>
   </p:cSld>
   <p:clrMapOvr>
     <a:masterClrMapping/>
   </p:clrMapOvr>
+  <p:transition>
+    <p14:cube dir="d"/>
+  </p:transition>
+  <p:timing>
+    <p:tnLst>
+      <p:par>
+        <p:cTn id="1" dur="indefinite" restart="never" nodeType="tmRoot">
+          <p:childTnLst>
+            <p:seq concurrent="1" nextAc="seek">
+              <p:cTn id="2" dur="indefinite" nodeType="mainSeq">
+                <p:childTnLst>
+                  <p:par>
+                    <p:cTn id="3" fill="hold">
+                      <p:stCondLst>
+                        <p:cond delay="0"/>
+                      </p:stCondLst>
+                      <p:childTnLst>
+                        <p:par>
+                          <p:cTn id="4" fill="hold">
+                            <p:stCondLst>
+                              <p:cond delay="500"/>
+                            </p:stCondLst>
+                            <p:childTnLst>
+                              <p:par>
+                                <p:cTn id="5" presetID="2" presetClass="entr" presetSubtype="4" fill="hold" grpId="0" nodeType="withEffect">
+                                  <p:stCondLst>
+                                    <p:cond delay="0"/>
+                                  </p:stCondLst>
+                                  <p:childTnLst>
+                                    <p:set>
+                                      <p:cBhvr>
+                                        <p:cTn id="6" dur="1" fill="hold">
+                                          <p:stCondLst>
+                                            <p:cond delay="0"/>
+                                          </p:stCondLst>
+                                        </p:cTn>
+                                        <p:tgtEl>
+                                          <p:spTgt spid="3">
+                                            <p:txEl>
+                                              <p:pRg st="0" end="0"/>
+                                            </p:txEl>
+                                          </p:spTgt>
+                                        </p:tgtEl>
+                                        <p:attrNameLst>
+                                          <p:attrName>style.visibility</p:attrName>
+                                        </p:attrNameLst>
+                                      </p:cBhvr>
+                                      <p:to>
+                                        <p:strVal val="visible"/>
+                                      </p:to>
+                                    </p:set>
+                                    <p:anim calcmode="lin" valueType="num">
+                                      <p:cBhvr additive="base">
+                                        <p:cTn id="7" dur="750" fill="hold"/>
+                                        <p:tgtEl>
+                                          <p:spTgt spid="3">
+                                            <p:txEl>
+                                              <p:pRg st="0" end="0"/>
+                                            </p:txEl>
+                                          </p:spTgt>
+                                        </p:tgtEl>
+                                        <p:attrNameLst>
+                                          <p:attrName>ppt_x</p:attrName>
+                                        </p:attrNameLst>
+                                      </p:cBhvr>
+                                      <p:tavLst>
+                                        <p:tav tm="0">
+                                          <p:val>
+                                            <p:strVal val="#ppt_x"/>
+                                          </p:val>
+                                        </p:tav>
+                                        <p:tav tm="100000">
+                                          <p:val>
+                                            <p:strVal val="#ppt_x"/>
+                                          </p:val>
+                                        </p:tav>
+                                      </p:tavLst>
+                                    </p:anim>
+                                    <p:anim calcmode="lin" valueType="num">
+                                      <p:cBhvr additive="base">
+                                        <p:cTn id="8" dur="750" fill="hold"/>
+                                        <p:tgtEl>
+                                          <p:spTgt spid="3">
+                                            <p:txEl>
+                                              <p:pRg st="0" end="0"/>
+                                            </p:txEl>
+                                          </p:spTgt>
+                                        </p:tgtEl>
+                                        <p:attrNameLst>
+                                          <p:attrName>ppt_y</p:attrName>
+                                        </p:attrNameLst>
+                                      </p:cBhvr>
+                                      <p:tavLst>
+                                        <p:tav tm="0">
+                                          <p:val>
+                                            <p:strVal val="1+#ppt_h/2"/>
+                                          </p:val>
+                                        </p:tav>
+                                        <p:tav tm="100000">
+                                          <p:val>
+                                            <p:strVal val="#ppt_y"/>
+                                          </p:val>
+                                        </p:tav>
+                                      </p:tavLst>
+                                    </p:anim>
+                                  </p:childTnLst>
+                                </p:cTn>
+                              </p:par>
+                            </p:childTnLst>
+                          </p:cTn>
+                        </p:par>
+                      </p:childTnLst>
+                    </p:cTn>
+                  </p:par>
+                  <p:par>
+                    <p:cTn id="9" fill="hold">
+                      <p:stCondLst>
+                        <p:cond delay="0"/>
+                      </p:stCondLst>
+                      <p:childTnLst>
+                        <p:par>
+                          <p:cTn id="10" fill="hold">
+                            <p:stCondLst>
+                              <p:cond delay="500"/>
+                            </p:stCondLst>
+                            <p:childTnLst>
+                              <p:par>
+                                <p:cTn id="11" presetID="2" presetClass="entr" presetSubtype="4" fill="hold" grpId="0" nodeType="withEffect">
+                                  <p:stCondLst>
+                                    <p:cond delay="0"/>
+                                  </p:stCondLst>
+                                  <p:childTnLst>
+                                    <p:set>
+                                      <p:cBhvr>
+                                        <p:cTn id="12" dur="1" fill="hold">
+                                          <p:stCondLst>
+                                            <p:cond delay="0"/>
+                                          </p:stCondLst>
+                                        </p:cTn>
+                                        <p:tgtEl>
+                                          <p:spTgt spid="3">
+                                            <p:txEl>
+                                              <p:pRg st="1" end="1"/>
+                                            </p:txEl>
+                                          </p:spTgt>
+                                        </p:tgtEl>
+                                        <p:attrNameLst>
+                                          <p:attrName>style.visibility</p:attrName>
+                                        </p:attrNameLst>
+                                      </p:cBhvr>
+                                      <p:to>
+                                        <p:strVal val="visible"/>
+                                      </p:to>
+                                    </p:set>
+                                    <p:anim calcmode="lin" valueType="num">
+                                      <p:cBhvr additive="base">
+                                        <p:cTn id="13" dur="750" fill="hold"/>
+                                        <p:tgtEl>
+                                          <p:spTgt spid="3">
+                                            <p:txEl>
+                                              <p:pRg st="1" end="1"/>
+                                            </p:txEl>
+                                          </p:spTgt>
+                                        </p:tgtEl>
+                                        <p:attrNameLst>
+                                          <p:attrName>ppt_x</p:attrName>
+                                        </p:attrNameLst>
+                                      </p:cBhvr>
+                                      <p:tavLst>
+                                        <p:tav tm="0">
+                                          <p:val>
+                                            <p:strVal val="#ppt_x"/>
+                                          </p:val>
+                                        </p:tav>
+                                        <p:tav tm="100000">
+                                          <p:val>
+                                            <p:strVal val="#ppt_x"/>
+                                          </p:val>
+                                        </p:tav>
+                                      </p:tavLst>
+                                    </p:anim>
+                                    <p:anim calcmode="lin" valueType="num">
+                                      <p:cBhvr additive="base">
+                                        <p:cTn id="14" dur="750" fill="hold"/>
+                                        <p:tgtEl>
+                                          <p:spTgt spid="3">
+                                            <p:txEl>
+                                              <p:pRg st="1" end="1"/>
+                                            </p:txEl>
+                                          </p:spTgt>
+                                        </p:tgtEl>
+                                        <p:attrNameLst>
+                                          <p:attrName>ppt_y</p:attrName>
+                                        </p:attrNameLst>
+                                      </p:cBhvr>
+                                      <p:tavLst>
+                                        <p:tav tm="0">
+                                          <p:val>
+                                            <p:strVal val="1+#ppt_h/2"/>
+                                          </p:val>
+                                        </p:tav>
+                                        <p:tav tm="100000">
+                                          <p:val>
+                                            <p:strVal val="#ppt_y"/>
+                                          </p:val>
+                                        </p:tav>
+                                      </p:tavLst>
+                                    </p:anim>
+                                  </p:childTnLst>
+                                </p:cTn>
+                              </p:par>
+                            </p:childTnLst>
+                          </p:cTn>
+                        </p:par>
+                      </p:childTnLst>
+                    </p:cTn>
+                  </p:par>
+                  <p:par>
+                    <p:cTn id="15" fill="hold">
+                      <p:stCondLst>
+                        <p:cond delay="0"/>
+                      </p:stCondLst>
+                      <p:childTnLst>
+                        <p:par>
+                          <p:cTn id="16" fill="hold">
+                            <p:stCondLst>
+                              <p:cond delay="500"/>
+                            </p:stCondLst>
+                            <p:childTnLst>
+                              <p:par>
+                                <p:cTn id="17" presetID="2" presetClass="entr" presetSubtype="4" fill="hold" grpId="0" nodeType="withEffect">
+                                  <p:stCondLst>
+                                    <p:cond delay="0"/>
+                                  </p:stCondLst>
+                                  <p:childTnLst>
+                                    <p:set>
+                                      <p:cBhvr>
+                                        <p:cTn id="18" dur="1" fill="hold">
+                                          <p:stCondLst>
+                                            <p:cond delay="0"/>
+                                          </p:stCondLst>
+                                        </p:cTn>
+                                        <p:tgtEl>
+                                          <p:spTgt spid="3">
+                                            <p:txEl>
+                                              <p:pRg st="2" end="2"/>
+                                            </p:txEl>
+                                          </p:spTgt>
+                                        </p:tgtEl>
+                                        <p:attrNameLst>
+                                          <p:attrName>style.visibility</p:attrName>
+                                        </p:attrNameLst>
+                                      </p:cBhvr>
+                                      <p:to>
+                                        <p:strVal val="visible"/>
+                                      </p:to>
+                                    </p:set>
+                                    <p:anim calcmode="lin" valueType="num">
+                                      <p:cBhvr additive="base">
+                                        <p:cTn id="19" dur="750" fill="hold"/>
+                                        <p:tgtEl>
+                                          <p:spTgt spid="3">
+                                            <p:txEl>
+                                              <p:pRg st="2" end="2"/>
+                                            </p:txEl>
+                                          </p:spTgt>
+                                        </p:tgtEl>
+                                        <p:attrNameLst>
+                                          <p:attrName>ppt_x</p:attrName>
+                                        </p:attrNameLst>
+                                      </p:cBhvr>
+                                      <p:tavLst>
+                                        <p:tav tm="0">
+                                          <p:val>
+                                            <p:strVal val="#ppt_x"/>
+                                          </p:val>
+                                        </p:tav>
+                                        <p:tav tm="100000">
+                                          <p:val>
+                                            <p:strVal val="#ppt_x"/>
+                                          </p:val>
+                                        </p:tav>
+                                      </p:tavLst>
+                                    </p:anim>
+                                    <p:anim calcmode="lin" valueType="num">
+                                      <p:cBhvr additive="base">
+                                        <p:cTn id="20" dur="750" fill="hold"/>
+                                        <p:tgtEl>
+                                          <p:spTgt spid="3">
+                                            <p:txEl>
+                                              <p:pRg st="2" end="2"/>
+                                            </p:txEl>
+                                          </p:spTgt>
+                                        </p:tgtEl>
+                                        <p:attrNameLst>
+                                          <p:attrName>ppt_y</p:attrName>
+                                        </p:attrNameLst>
+                                      </p:cBhvr>
+                                      <p:tavLst>
+                                        <p:tav tm="0">
+                                          <p:val>
+                                            <p:strVal val="1+#ppt_h/2"/>
+                                          </p:val>
+                                        </p:tav>
+                                        <p:tav tm="100000">
+                                          <p:val>
+                                            <p:strVal val="#ppt_y"/>
+                                          </p:val>
+                                        </p:tav>
+                                      </p:tavLst>
+                                    </p:anim>
+                                  </p:childTnLst>
+                                </p:cTn>
+                              </p:par>
+                            </p:childTnLst>
+                          </p:cTn>
+                        </p:par>
+                      </p:childTnLst>
+                    </p:cTn>
+                  </p:par>
+                  <p:par>
+                    <p:cTn id="21" fill="hold">
+                      <p:stCondLst>
+                        <p:cond delay="0"/>
+                      </p:stCondLst>
+                      <p:childTnLst>
+                        <p:par>
+                          <p:cTn id="22" fill="hold">
+                            <p:stCondLst>
+                              <p:cond delay="500"/>
+                            </p:stCondLst>
+                            <p:childTnLst>
+                              <p:par>
+                                <p:cTn id="23" presetID="2" presetClass="entr" presetSubtype="4" fill="hold" grpId="0" nodeType="withEffect">
+                                  <p:stCondLst>
+                                    <p:cond delay="0"/>
+                                  </p:stCondLst>
+                                  <p:childTnLst>
+                                    <p:set>
+                                      <p:cBhvr>
+                                        <p:cTn id="24" dur="1" fill="hold">
+                                          <p:stCondLst>
+                                            <p:cond delay="0"/>
+                                          </p:stCondLst>
+                                        </p:cTn>
+                                        <p:tgtEl>
+                                          <p:spTgt spid="3">
+                                            <p:txEl>
+                                              <p:pRg st="3" end="3"/>
+                                            </p:txEl>
+                                          </p:spTgt>
+                                        </p:tgtEl>
+                                        <p:attrNameLst>
+                                          <p:attrName>style.visibility</p:attrName>
+                                        </p:attrNameLst>
+                                      </p:cBhvr>
+                                      <p:to>
+                                        <p:strVal val="visible"/>
+                                      </p:to>
+                                    </p:set>
+                                    <p:anim calcmode="lin" valueType="num">
+                                      <p:cBhvr additive="base">
+                                        <p:cTn id="25" dur="750" fill="hold"/>
+                                        <p:tgtEl>
+                                          <p:spTgt spid="3">
+                                            <p:txEl>
+                                              <p:pRg st="3" end="3"/>
+                                            </p:txEl>
+                                          </p:spTgt>
+                                        </p:tgtEl>
+                                        <p:attrNameLst>
+                                          <p:attrName>ppt_x</p:attrName>
+                                        </p:attrNameLst>
+                                      </p:cBhvr>
+                                      <p:tavLst>
+                                        <p:tav tm="0">
+                                          <p:val>
+                                            <p:strVal val="#ppt_x"/>
+                                          </p:val>
+                                        </p:tav>
+                                        <p:tav tm="100000">
+                                          <p:val>
+                                            <p:strVal val="#ppt_x"/>
+                                          </p:val>
+                                        </p:tav>
+                                      </p:tavLst>
+                                    </p:anim>
+                                    <p:anim calcmode="lin" valueType="num">
+                                      <p:cBhvr additive="base">
+                                        <p:cTn id="26" dur="750" fill="hold"/>
+                                        <p:tgtEl>
+                                          <p:spTgt spid="3">
+                                            <p:txEl>
+                                              <p:pRg st="3" end="3"/>
+                                            </p:txEl>
+                                          </p:spTgt>
+                                        </p:tgtEl>
+                                        <p:attrNameLst>
+                                          <p:attrName>ppt_y</p:attrName>
+                                        </p:attrNameLst>
+                                      </p:cBhvr>
+                                      <p:tavLst>
+                                        <p:tav tm="0">
+                                          <p:val>
+                                            <p:strVal val="1+#ppt_h/2"/>
+                                          </p:val>
+                                        </p:tav>
+                                        <p:tav tm="100000">
+                                          <p:val>
+                                            <p:strVal val="#ppt_y"/>
+                                          </p:val>
+                                        </p:tav>
+                                      </p:tavLst>
+                                    </p:anim>
+                                  </p:childTnLst>
+                                </p:cTn>
+                              </p:par>
+                            </p:childTnLst>
+                          </p:cTn>
+                        </p:par>
+                      </p:childTnLst>
+                    </p:cTn>
+                  </p:par>
+                </p:childTnLst>
+              </p:cTn>
+              <p:prevCondLst>
+                <p:cond evt="onPrev" delay="0">
+                  <p:tgtEl>
+                    <p:sldTgt/>
+                  </p:tgtEl>
+                </p:cond>
+              </p:prevCondLst>
+              <p:nextCondLst>
+                <p:cond evt="onNext" delay="0">
+                  <p:tgtEl>
+                    <p:sldTgt/>
+                  </p:tgtEl>
+                </p:cond>
+              </p:nextCondLst>
+            </p:seq>
+          </p:childTnLst>
+        </p:cTn>
+      </p:par>
+    </p:tnLst>
+  </p:timing>
 </p:sld>
 </file>
 
 <file path=ppt/slides/slide7.xml><?xml version="1.0" encoding="utf-8"?>
-<p:sld xmlns:a="http://schemas.openxmlformats.org/drawingml/2006/main" xmlns:r="http://schemas.openxmlformats.org/officeDocument/2006/relationships" xmlns:p="http://schemas.openxmlformats.org/presentationml/2006/main">
+<p:sld xmlns:a="http://schemas.openxmlformats.org/drawingml/2006/main" xmlns:a14="http://schemas.microsoft.com/office/drawing/2010/main" xmlns:a16="http://schemas.microsoft.com/office/drawing/2014/main" xmlns:p="http://schemas.openxmlformats.org/presentationml/2006/main" xmlns:p14="http://schemas.microsoft.com/office/powerpoint/2010/main" xmlns:r="http://schemas.openxmlformats.org/officeDocument/2006/relationships">
   <p:cSld>
     <p:bg>
       <p:bgPr>
@@ -6828,7 +8573,7 @@
           <p:cNvPr id="2" name="Title 1" descr="M87mPQOGcgY1wRZ7a9VM6nx3U0/dC3FTFU3aFe71lAScHLhkFjmsli0fvn314KIA3WdPGKX5rdsEUWhwrqY9rBM+qOvs5RvQ-~WT/IUdUj7uiaGf77SfzSHg==">
             <a:extLst>
               <a:ext uri="{FF2B5EF4-FFF2-40B4-BE49-F238E27FC236}">
-                <a16:creationId xmlns:a16="http://schemas.microsoft.com/office/drawing/2014/main" id="{6E32CB19-CC60-4758-8E36-88BF6DFEBAE2}"/>
+                <a16:creationId id="{6E32CB19-CC60-4758-8E36-88BF6DFEBAE2}"/>
               </a:ext>
             </a:extLst>
           </p:cNvPr>
@@ -6885,7 +8630,7 @@
           <p:cNvPr id="18" name="TextBox 17" descr="YASKxbdsoDRMc/ZDOkvTVyC43/kzZu8bBvzNlUdQMAubanJQMHWj16wFahNwHCv0LNb4RpBcOXPakftOsHA+6Si8Cfxx1sDz-~AjQttWtwgp+UjdPabuEXfw==">
             <a:extLst>
               <a:ext uri="{FF2B5EF4-FFF2-40B4-BE49-F238E27FC236}">
-                <a16:creationId xmlns:a16="http://schemas.microsoft.com/office/drawing/2014/main" id="{DC8A396E-CEC9-428C-B584-7FD5A4015E71}"/>
+                <a16:creationId id="{DC8A396E-CEC9-428C-B584-7FD5A4015E71}"/>
               </a:ext>
             </a:extLst>
           </p:cNvPr>
@@ -6986,7 +8731,7 @@
           <p:cNvPr id="20" name="TextBox 19" descr="4xK1O6nl4whS9XOOTdH7f/8bocA6PXSiKiO7jUTW4GpinljZLVLxh8+7Oz8s0UyObglXd2oy8iA1wXeTrsLcBOi4dFzt5rGI-~WaP5wUK5nQyFjk1UkxqxDg==">
             <a:extLst>
               <a:ext uri="{FF2B5EF4-FFF2-40B4-BE49-F238E27FC236}">
-                <a16:creationId xmlns:a16="http://schemas.microsoft.com/office/drawing/2014/main" id="{19B325D1-9B9A-4B7D-8DB5-8654ACB5B2C1}"/>
+                <a16:creationId id="{19B325D1-9B9A-4B7D-8DB5-8654ACB5B2C1}"/>
               </a:ext>
             </a:extLst>
           </p:cNvPr>
@@ -7087,7 +8832,7 @@
           <p:cNvPr id="22" name="TextBox 21" descr="4oseAYVe9YcZAouaJ001PkCae1BKSGElWoTRBZBDH651oTSM/3RVbrvPm+yi+qaRjrkl50oMPB81itbVqo1jX3cKm+3QVhH9-~Ki/NiFx8Cx5irvYQDyAr+w==">
             <a:extLst>
               <a:ext uri="{FF2B5EF4-FFF2-40B4-BE49-F238E27FC236}">
-                <a16:creationId xmlns:a16="http://schemas.microsoft.com/office/drawing/2014/main" id="{EB01A93F-3BDC-4A31-A3D9-2F91D8E9AD3F}"/>
+                <a16:creationId id="{EB01A93F-3BDC-4A31-A3D9-2F91D8E9AD3F}"/>
               </a:ext>
             </a:extLst>
           </p:cNvPr>
@@ -7188,7 +8933,7 @@
           <p:cNvPr id="24" name="TextBox 23" descr="XIv/4FX2e5V4E/kzCdIKraoy1CmGI9EdjlWzri4UZ07zrY+DEDABHMWd02r5B/V+xAi8/gSiZsNJvOCWl0hDs81DqSL9XwBO-~MJAvlVo1TaVakDhQ/9qcNQ==">
             <a:extLst>
               <a:ext uri="{FF2B5EF4-FFF2-40B4-BE49-F238E27FC236}">
-                <a16:creationId xmlns:a16="http://schemas.microsoft.com/office/drawing/2014/main" id="{0A281D8A-5FDB-4127-9CE2-80767A355A45}"/>
+                <a16:creationId id="{0A281D8A-5FDB-4127-9CE2-80767A355A45}"/>
               </a:ext>
             </a:extLst>
           </p:cNvPr>
@@ -7289,7 +9034,7 @@
           <p:cNvPr id="3" name="Picture 2#@#CSgbZAlefeWFKgC0IYVgjxjuc6/nHTyB7CHcn1Ojr9h9i+PHQ1voTsT3wTyvEKGBy6GlUWkaJ5vTT8RkywdsN16gBtveZuFz-~IvEy/WyBzw7ksUqXn6ErpQ==" descr="A picture containing food, drawing, flower&#10;&#10;Description automatically generated">
             <a:extLst>
               <a:ext uri="{FF2B5EF4-FFF2-40B4-BE49-F238E27FC236}">
-                <a16:creationId xmlns:a16="http://schemas.microsoft.com/office/drawing/2014/main" id="{C3C2919A-22E7-4066-8B6A-B734DCC6AACF}"/>
+                <a16:creationId id="{C3C2919A-22E7-4066-8B6A-B734DCC6AACF}"/>
               </a:ext>
             </a:extLst>
           </p:cNvPr>
@@ -7302,7 +9047,7 @@
           <a:blip r:embed="rId3">
             <a:extLst>
               <a:ext uri="{28A0092B-C50C-407E-A947-70E740481C1C}">
-                <a14:useLocalDpi xmlns:a14="http://schemas.microsoft.com/office/drawing/2010/main"/>
+                <a14:useLocalDpi/>
               </a:ext>
             </a:extLst>
           </a:blip>
@@ -7325,7 +9070,7 @@
           <p:cNvPr id="5" name="Straight Connector 4" descr="2OBg0tZQLJQlgsmSLMaR/0KR93vg0DQr31sWArPmI3dHNAkxEKMih/92GcaaTU047GL458bgeNFRrh+CKrfDGyLTEZMFxTLm-~35Ok14IMGpQm+TORjPW0QA==">
             <a:extLst>
               <a:ext uri="{FF2B5EF4-FFF2-40B4-BE49-F238E27FC236}">
-                <a16:creationId xmlns:a16="http://schemas.microsoft.com/office/drawing/2014/main" id="{E9C286A9-43C6-469D-92DE-7E0D7F46EF39}"/>
+                <a16:creationId id="{E9C286A9-43C6-469D-92DE-7E0D7F46EF39}"/>
               </a:ext>
             </a:extLst>
           </p:cNvPr>
@@ -7361,7 +9106,7 @@
           <p:cNvPr id="10" name="Straight Connector 9" descr="lRd2liWLz80x9GL7b9d4ns5zRHWPybb5IfbaliVkbQYAJ0YhSUqUiBNery7ZEDKvlN5lq1fsmF19igeIbVrC0bdc97eiSQqm-~fJpBLh2ZziCmazhpXqn0JQ==">
             <a:extLst>
               <a:ext uri="{FF2B5EF4-FFF2-40B4-BE49-F238E27FC236}">
-                <a16:creationId xmlns:a16="http://schemas.microsoft.com/office/drawing/2014/main" id="{D32E4593-98CD-4BCD-936B-4244C6B29B4B}"/>
+                <a16:creationId id="{D32E4593-98CD-4BCD-936B-4244C6B29B4B}"/>
               </a:ext>
             </a:extLst>
           </p:cNvPr>
@@ -7397,7 +9142,7 @@
           <p:cNvPr id="11" name="Straight Connector 10" descr="jVAEVpWos7D92SMvz5LIxc2o18PDFwnTslb+AX5bL/RFpERKwqoYnmf9oI8p/iLYofMW62VNF8neQzxbnOS982Le0E0YlexU-~OxFf3XtCv230WmFCutxgVw==">
             <a:extLst>
               <a:ext uri="{FF2B5EF4-FFF2-40B4-BE49-F238E27FC236}">
-                <a16:creationId xmlns:a16="http://schemas.microsoft.com/office/drawing/2014/main" id="{F2C536CB-54BA-464D-90A9-FB12928F77A8}"/>
+                <a16:creationId id="{F2C536CB-54BA-464D-90A9-FB12928F77A8}"/>
               </a:ext>
             </a:extLst>
           </p:cNvPr>
@@ -7433,7 +9178,7 @@
           <p:cNvPr id="12" name="Straight Connector 11" descr="UVSKLgjXitFgFRbumXRbvSHX2hS+nWSsUCsWXb1G9HWoTBfeZb8BvEd+eli5Cqdgqg1Xk7EB1IZ3mSNB8kBW+7ry6sD9oPj1-~aDO3b/6FvEhSCkmvVN1CXQ==">
             <a:extLst>
               <a:ext uri="{FF2B5EF4-FFF2-40B4-BE49-F238E27FC236}">
-                <a16:creationId xmlns:a16="http://schemas.microsoft.com/office/drawing/2014/main" id="{37579A13-8F10-4B9C-9862-E5BC2B0BE962}"/>
+                <a16:creationId id="{37579A13-8F10-4B9C-9862-E5BC2B0BE962}"/>
               </a:ext>
             </a:extLst>
           </p:cNvPr>
@@ -7469,7 +9214,7 @@
           <p:cNvPr id="13" name="Straight Connector 12" descr="QXsGyKPhQHpk2S+jPdT3pm+FsoMthx7EFKd9TQhha7MVu+S0ahBEwfI1AHWU9H6riQrwJBg0/X8eFpQ881v8d6HtxQzS3OWx-~eP3ZWxfUFLsN0ZWQoiXW/w==">
             <a:extLst>
               <a:ext uri="{FF2B5EF4-FFF2-40B4-BE49-F238E27FC236}">
-                <a16:creationId xmlns:a16="http://schemas.microsoft.com/office/drawing/2014/main" id="{D3C66B51-AFEC-4218-A88C-C805FB0077BD}"/>
+                <a16:creationId id="{D3C66B51-AFEC-4218-A88C-C805FB0077BD}"/>
               </a:ext>
             </a:extLst>
           </p:cNvPr>
@@ -7505,7 +9250,7 @@
           <p:cNvPr id="14" name="Straight Connector 13" descr="po4Y8iKunyyMOROqAdq6qftsauOmx+MxKteFcN2qoGT6FtZm45R0NtoRBWg2vRaZUVUW3zhoFc762AZcjQqhfQi7F8CZtwPp-~ntlsbva1RBEyhcjB13tu6g==">
             <a:extLst>
               <a:ext uri="{FF2B5EF4-FFF2-40B4-BE49-F238E27FC236}">
-                <a16:creationId xmlns:a16="http://schemas.microsoft.com/office/drawing/2014/main" id="{10AEFFBC-3BA6-4C51-8C45-1E8F185B559D}"/>
+                <a16:creationId id="{10AEFFBC-3BA6-4C51-8C45-1E8F185B559D}"/>
               </a:ext>
             </a:extLst>
           </p:cNvPr>
@@ -7539,18 +9284,21 @@
     </p:spTree>
     <p:extLst>
       <p:ext uri="{BB962C8B-B14F-4D97-AF65-F5344CB8AC3E}">
-        <p14:creationId xmlns:p14="http://schemas.microsoft.com/office/powerpoint/2010/main" val="2212093181"/>
+        <p14:creationId val="2212093181"/>
       </p:ext>
     </p:extLst>
   </p:cSld>
   <p:clrMapOvr>
     <a:masterClrMapping/>
   </p:clrMapOvr>
+  <p:transition>
+    <p14:cube dir="d"/>
+  </p:transition>
 </p:sld>
 </file>
 
 <file path=ppt/slides/slide8.xml><?xml version="1.0" encoding="utf-8"?>
-<p:sld xmlns:a="http://schemas.openxmlformats.org/drawingml/2006/main" xmlns:r="http://schemas.openxmlformats.org/officeDocument/2006/relationships" xmlns:p="http://schemas.openxmlformats.org/presentationml/2006/main">
+<p:sld xmlns:a="http://schemas.openxmlformats.org/drawingml/2006/main" xmlns:a14="http://schemas.microsoft.com/office/drawing/2010/main" xmlns:a16="http://schemas.microsoft.com/office/drawing/2014/main" xmlns:p="http://schemas.openxmlformats.org/presentationml/2006/main" xmlns:p14="http://schemas.microsoft.com/office/powerpoint/2010/main" xmlns:r="http://schemas.openxmlformats.org/officeDocument/2006/relationships">
   <p:cSld>
     <p:bg>
       <p:bgPr>
@@ -7579,7 +9327,7 @@
           <p:cNvPr id="2" name="Title 1" descr="7iRYjr38Gu3RrzHmzrSP96oulIn8EwB3ihIpzR4mnyJyrcUGx/JwlcZbnlGBH+3Hdqgduq4ZqvwxpC8rNJSh4UrTUC8bC7Oo-~s3FP3q3IMgRQvGd/4yVZQA==">
             <a:extLst>
               <a:ext uri="{FF2B5EF4-FFF2-40B4-BE49-F238E27FC236}">
-                <a16:creationId xmlns:a16="http://schemas.microsoft.com/office/drawing/2014/main" id="{6E32CB19-CC60-4758-8E36-88BF6DFEBAE2}"/>
+                <a16:creationId id="{6E32CB19-CC60-4758-8E36-88BF6DFEBAE2}"/>
               </a:ext>
             </a:extLst>
           </p:cNvPr>
@@ -7617,15 +9365,12 @@
           <a:lstStyle/>
           <a:p>
             <a:r>
-              <a:rPr lang="en-US" sz="4800" dirty="0">
-                <a:solidFill>
-                  <a:schemeClr val="accent1">
-                    <a:lumMod val="40000"/>
-                    <a:lumOff val="60000"/>
-                  </a:schemeClr>
-                </a:solidFill>
+              <a:rPr lang="en-US" sz="6600" dirty="0" b="1">
                 <a:latin typeface="+mj-lt"/>
                 <a:cs typeface="Aharoni" panose="02010803020104030203" pitchFamily="2" charset="-79"/>
+                <a:solidFill>
+                  <a:schemeClr val="tx1"/>
+                </a:solidFill>
               </a:rPr>
               <a:t>Proximity</a:t>
             </a:r>
@@ -7637,7 +9382,7 @@
           <p:cNvPr id="3" name="Content Placeholder 2" descr="2I4tL5s5vQKwYWjNQ1kfucfLb7wCXIrztL7kQAaO8j4+9mSEzE58jxLhXShnhPd/i/ujIMnxQVWTI5vtED5NVpASPDFZeS7y-~Fee2m5TwAvPUH0fH75p52A==">
             <a:extLst>
               <a:ext uri="{FF2B5EF4-FFF2-40B4-BE49-F238E27FC236}">
-                <a16:creationId xmlns:a16="http://schemas.microsoft.com/office/drawing/2014/main" id="{70A0772C-BE9D-43F0-8427-9FF7403CB2FF}"/>
+                <a16:creationId id="{70A0772C-BE9D-43F0-8427-9FF7403CB2FF}"/>
               </a:ext>
             </a:extLst>
           </p:cNvPr>
@@ -7759,7 +9504,7 @@
           <p:cNvPr id="6" name="Picture 5#@#AQdqBVpUvR/bSAVOyJ8FgBkaKFPfKjgOpysJXEfi+aeQGHqROhyd0f7WmN/ECHEi/74bucfwgpLx6HJoNhPt/WTpEhxhwHuY-~AgQYqvhTEz5/aQ3HmY2ZRA==" descr="A picture containing food, drawing, flower&#10;&#10;Description automatically generated">
             <a:extLst>
               <a:ext uri="{FF2B5EF4-FFF2-40B4-BE49-F238E27FC236}">
-                <a16:creationId xmlns:a16="http://schemas.microsoft.com/office/drawing/2014/main" id="{3F7FF4C5-2A2D-409B-A367-AA9830E7FA3C}"/>
+                <a16:creationId id="{3F7FF4C5-2A2D-409B-A367-AA9830E7FA3C}"/>
               </a:ext>
             </a:extLst>
           </p:cNvPr>
@@ -7772,7 +9517,7 @@
           <a:blip r:embed="rId3">
             <a:extLst>
               <a:ext uri="{28A0092B-C50C-407E-A947-70E740481C1C}">
-                <a14:useLocalDpi xmlns:a14="http://schemas.microsoft.com/office/drawing/2010/main"/>
+                <a14:useLocalDpi/>
               </a:ext>
             </a:extLst>
           </a:blip>
@@ -7793,18 +9538,463 @@
     </p:spTree>
     <p:extLst>
       <p:ext uri="{BB962C8B-B14F-4D97-AF65-F5344CB8AC3E}">
-        <p14:creationId xmlns:p14="http://schemas.microsoft.com/office/powerpoint/2010/main" val="2499250591"/>
+        <p14:creationId val="2499250591"/>
       </p:ext>
     </p:extLst>
   </p:cSld>
   <p:clrMapOvr>
     <a:masterClrMapping/>
   </p:clrMapOvr>
+  <p:transition>
+    <p14:cube dir="d"/>
+  </p:transition>
+  <p:timing>
+    <p:tnLst>
+      <p:par>
+        <p:cTn id="1" dur="indefinite" restart="never" nodeType="tmRoot">
+          <p:childTnLst>
+            <p:seq concurrent="1" nextAc="seek">
+              <p:cTn id="2" dur="indefinite" nodeType="mainSeq">
+                <p:childTnLst>
+                  <p:par>
+                    <p:cTn id="3" fill="hold">
+                      <p:stCondLst>
+                        <p:cond delay="0"/>
+                      </p:stCondLst>
+                      <p:childTnLst>
+                        <p:par>
+                          <p:cTn id="4" fill="hold">
+                            <p:stCondLst>
+                              <p:cond delay="500"/>
+                            </p:stCondLst>
+                            <p:childTnLst>
+                              <p:par>
+                                <p:cTn id="5" presetID="2" presetClass="entr" presetSubtype="4" fill="hold" grpId="0" nodeType="withEffect">
+                                  <p:stCondLst>
+                                    <p:cond delay="0"/>
+                                  </p:stCondLst>
+                                  <p:childTnLst>
+                                    <p:set>
+                                      <p:cBhvr>
+                                        <p:cTn id="6" dur="1" fill="hold">
+                                          <p:stCondLst>
+                                            <p:cond delay="0"/>
+                                          </p:stCondLst>
+                                        </p:cTn>
+                                        <p:tgtEl>
+                                          <p:spTgt spid="3">
+                                            <p:txEl>
+                                              <p:pRg st="0" end="0"/>
+                                            </p:txEl>
+                                          </p:spTgt>
+                                        </p:tgtEl>
+                                        <p:attrNameLst>
+                                          <p:attrName>style.visibility</p:attrName>
+                                        </p:attrNameLst>
+                                      </p:cBhvr>
+                                      <p:to>
+                                        <p:strVal val="visible"/>
+                                      </p:to>
+                                    </p:set>
+                                    <p:anim calcmode="lin" valueType="num">
+                                      <p:cBhvr additive="base">
+                                        <p:cTn id="7" dur="750" fill="hold"/>
+                                        <p:tgtEl>
+                                          <p:spTgt spid="3">
+                                            <p:txEl>
+                                              <p:pRg st="0" end="0"/>
+                                            </p:txEl>
+                                          </p:spTgt>
+                                        </p:tgtEl>
+                                        <p:attrNameLst>
+                                          <p:attrName>ppt_x</p:attrName>
+                                        </p:attrNameLst>
+                                      </p:cBhvr>
+                                      <p:tavLst>
+                                        <p:tav tm="0">
+                                          <p:val>
+                                            <p:strVal val="#ppt_x"/>
+                                          </p:val>
+                                        </p:tav>
+                                        <p:tav tm="100000">
+                                          <p:val>
+                                            <p:strVal val="#ppt_x"/>
+                                          </p:val>
+                                        </p:tav>
+                                      </p:tavLst>
+                                    </p:anim>
+                                    <p:anim calcmode="lin" valueType="num">
+                                      <p:cBhvr additive="base">
+                                        <p:cTn id="8" dur="750" fill="hold"/>
+                                        <p:tgtEl>
+                                          <p:spTgt spid="3">
+                                            <p:txEl>
+                                              <p:pRg st="0" end="0"/>
+                                            </p:txEl>
+                                          </p:spTgt>
+                                        </p:tgtEl>
+                                        <p:attrNameLst>
+                                          <p:attrName>ppt_y</p:attrName>
+                                        </p:attrNameLst>
+                                      </p:cBhvr>
+                                      <p:tavLst>
+                                        <p:tav tm="0">
+                                          <p:val>
+                                            <p:strVal val="1+#ppt_h/2"/>
+                                          </p:val>
+                                        </p:tav>
+                                        <p:tav tm="100000">
+                                          <p:val>
+                                            <p:strVal val="#ppt_y"/>
+                                          </p:val>
+                                        </p:tav>
+                                      </p:tavLst>
+                                    </p:anim>
+                                  </p:childTnLst>
+                                </p:cTn>
+                              </p:par>
+                            </p:childTnLst>
+                          </p:cTn>
+                        </p:par>
+                      </p:childTnLst>
+                    </p:cTn>
+                  </p:par>
+                  <p:par>
+                    <p:cTn id="9" fill="hold">
+                      <p:stCondLst>
+                        <p:cond delay="0"/>
+                      </p:stCondLst>
+                      <p:childTnLst>
+                        <p:par>
+                          <p:cTn id="10" fill="hold">
+                            <p:stCondLst>
+                              <p:cond delay="500"/>
+                            </p:stCondLst>
+                            <p:childTnLst>
+                              <p:par>
+                                <p:cTn id="11" presetID="2" presetClass="entr" presetSubtype="4" fill="hold" grpId="0" nodeType="withEffect">
+                                  <p:stCondLst>
+                                    <p:cond delay="0"/>
+                                  </p:stCondLst>
+                                  <p:childTnLst>
+                                    <p:set>
+                                      <p:cBhvr>
+                                        <p:cTn id="12" dur="1" fill="hold">
+                                          <p:stCondLst>
+                                            <p:cond delay="0"/>
+                                          </p:stCondLst>
+                                        </p:cTn>
+                                        <p:tgtEl>
+                                          <p:spTgt spid="3">
+                                            <p:txEl>
+                                              <p:pRg st="1" end="1"/>
+                                            </p:txEl>
+                                          </p:spTgt>
+                                        </p:tgtEl>
+                                        <p:attrNameLst>
+                                          <p:attrName>style.visibility</p:attrName>
+                                        </p:attrNameLst>
+                                      </p:cBhvr>
+                                      <p:to>
+                                        <p:strVal val="visible"/>
+                                      </p:to>
+                                    </p:set>
+                                    <p:anim calcmode="lin" valueType="num">
+                                      <p:cBhvr additive="base">
+                                        <p:cTn id="13" dur="750" fill="hold"/>
+                                        <p:tgtEl>
+                                          <p:spTgt spid="3">
+                                            <p:txEl>
+                                              <p:pRg st="1" end="1"/>
+                                            </p:txEl>
+                                          </p:spTgt>
+                                        </p:tgtEl>
+                                        <p:attrNameLst>
+                                          <p:attrName>ppt_x</p:attrName>
+                                        </p:attrNameLst>
+                                      </p:cBhvr>
+                                      <p:tavLst>
+                                        <p:tav tm="0">
+                                          <p:val>
+                                            <p:strVal val="#ppt_x"/>
+                                          </p:val>
+                                        </p:tav>
+                                        <p:tav tm="100000">
+                                          <p:val>
+                                            <p:strVal val="#ppt_x"/>
+                                          </p:val>
+                                        </p:tav>
+                                      </p:tavLst>
+                                    </p:anim>
+                                    <p:anim calcmode="lin" valueType="num">
+                                      <p:cBhvr additive="base">
+                                        <p:cTn id="14" dur="750" fill="hold"/>
+                                        <p:tgtEl>
+                                          <p:spTgt spid="3">
+                                            <p:txEl>
+                                              <p:pRg st="1" end="1"/>
+                                            </p:txEl>
+                                          </p:spTgt>
+                                        </p:tgtEl>
+                                        <p:attrNameLst>
+                                          <p:attrName>ppt_y</p:attrName>
+                                        </p:attrNameLst>
+                                      </p:cBhvr>
+                                      <p:tavLst>
+                                        <p:tav tm="0">
+                                          <p:val>
+                                            <p:strVal val="1+#ppt_h/2"/>
+                                          </p:val>
+                                        </p:tav>
+                                        <p:tav tm="100000">
+                                          <p:val>
+                                            <p:strVal val="#ppt_y"/>
+                                          </p:val>
+                                        </p:tav>
+                                      </p:tavLst>
+                                    </p:anim>
+                                  </p:childTnLst>
+                                </p:cTn>
+                              </p:par>
+                            </p:childTnLst>
+                          </p:cTn>
+                        </p:par>
+                      </p:childTnLst>
+                    </p:cTn>
+                  </p:par>
+                  <p:par>
+                    <p:cTn id="15" fill="hold">
+                      <p:stCondLst>
+                        <p:cond delay="0"/>
+                      </p:stCondLst>
+                      <p:childTnLst>
+                        <p:par>
+                          <p:cTn id="16" fill="hold">
+                            <p:stCondLst>
+                              <p:cond delay="500"/>
+                            </p:stCondLst>
+                            <p:childTnLst>
+                              <p:par>
+                                <p:cTn id="17" presetID="2" presetClass="entr" presetSubtype="4" fill="hold" grpId="0" nodeType="withEffect">
+                                  <p:stCondLst>
+                                    <p:cond delay="0"/>
+                                  </p:stCondLst>
+                                  <p:childTnLst>
+                                    <p:set>
+                                      <p:cBhvr>
+                                        <p:cTn id="18" dur="1" fill="hold">
+                                          <p:stCondLst>
+                                            <p:cond delay="0"/>
+                                          </p:stCondLst>
+                                        </p:cTn>
+                                        <p:tgtEl>
+                                          <p:spTgt spid="3">
+                                            <p:txEl>
+                                              <p:pRg st="2" end="2"/>
+                                            </p:txEl>
+                                          </p:spTgt>
+                                        </p:tgtEl>
+                                        <p:attrNameLst>
+                                          <p:attrName>style.visibility</p:attrName>
+                                        </p:attrNameLst>
+                                      </p:cBhvr>
+                                      <p:to>
+                                        <p:strVal val="visible"/>
+                                      </p:to>
+                                    </p:set>
+                                    <p:anim calcmode="lin" valueType="num">
+                                      <p:cBhvr additive="base">
+                                        <p:cTn id="19" dur="750" fill="hold"/>
+                                        <p:tgtEl>
+                                          <p:spTgt spid="3">
+                                            <p:txEl>
+                                              <p:pRg st="2" end="2"/>
+                                            </p:txEl>
+                                          </p:spTgt>
+                                        </p:tgtEl>
+                                        <p:attrNameLst>
+                                          <p:attrName>ppt_x</p:attrName>
+                                        </p:attrNameLst>
+                                      </p:cBhvr>
+                                      <p:tavLst>
+                                        <p:tav tm="0">
+                                          <p:val>
+                                            <p:strVal val="#ppt_x"/>
+                                          </p:val>
+                                        </p:tav>
+                                        <p:tav tm="100000">
+                                          <p:val>
+                                            <p:strVal val="#ppt_x"/>
+                                          </p:val>
+                                        </p:tav>
+                                      </p:tavLst>
+                                    </p:anim>
+                                    <p:anim calcmode="lin" valueType="num">
+                                      <p:cBhvr additive="base">
+                                        <p:cTn id="20" dur="750" fill="hold"/>
+                                        <p:tgtEl>
+                                          <p:spTgt spid="3">
+                                            <p:txEl>
+                                              <p:pRg st="2" end="2"/>
+                                            </p:txEl>
+                                          </p:spTgt>
+                                        </p:tgtEl>
+                                        <p:attrNameLst>
+                                          <p:attrName>ppt_y</p:attrName>
+                                        </p:attrNameLst>
+                                      </p:cBhvr>
+                                      <p:tavLst>
+                                        <p:tav tm="0">
+                                          <p:val>
+                                            <p:strVal val="1+#ppt_h/2"/>
+                                          </p:val>
+                                        </p:tav>
+                                        <p:tav tm="100000">
+                                          <p:val>
+                                            <p:strVal val="#ppt_y"/>
+                                          </p:val>
+                                        </p:tav>
+                                      </p:tavLst>
+                                    </p:anim>
+                                  </p:childTnLst>
+                                </p:cTn>
+                              </p:par>
+                            </p:childTnLst>
+                          </p:cTn>
+                        </p:par>
+                      </p:childTnLst>
+                    </p:cTn>
+                  </p:par>
+                  <p:par>
+                    <p:cTn id="21" fill="hold">
+                      <p:stCondLst>
+                        <p:cond delay="0"/>
+                      </p:stCondLst>
+                      <p:childTnLst>
+                        <p:par>
+                          <p:cTn id="22" fill="hold">
+                            <p:stCondLst>
+                              <p:cond delay="500"/>
+                            </p:stCondLst>
+                            <p:childTnLst>
+                              <p:par>
+                                <p:cTn id="23" presetID="2" presetClass="entr" presetSubtype="4" fill="hold" grpId="0" nodeType="withEffect">
+                                  <p:stCondLst>
+                                    <p:cond delay="0"/>
+                                  </p:stCondLst>
+                                  <p:childTnLst>
+                                    <p:set>
+                                      <p:cBhvr>
+                                        <p:cTn id="24" dur="1" fill="hold">
+                                          <p:stCondLst>
+                                            <p:cond delay="0"/>
+                                          </p:stCondLst>
+                                        </p:cTn>
+                                        <p:tgtEl>
+                                          <p:spTgt spid="3">
+                                            <p:txEl>
+                                              <p:pRg st="3" end="3"/>
+                                            </p:txEl>
+                                          </p:spTgt>
+                                        </p:tgtEl>
+                                        <p:attrNameLst>
+                                          <p:attrName>style.visibility</p:attrName>
+                                        </p:attrNameLst>
+                                      </p:cBhvr>
+                                      <p:to>
+                                        <p:strVal val="visible"/>
+                                      </p:to>
+                                    </p:set>
+                                    <p:anim calcmode="lin" valueType="num">
+                                      <p:cBhvr additive="base">
+                                        <p:cTn id="25" dur="750" fill="hold"/>
+                                        <p:tgtEl>
+                                          <p:spTgt spid="3">
+                                            <p:txEl>
+                                              <p:pRg st="3" end="3"/>
+                                            </p:txEl>
+                                          </p:spTgt>
+                                        </p:tgtEl>
+                                        <p:attrNameLst>
+                                          <p:attrName>ppt_x</p:attrName>
+                                        </p:attrNameLst>
+                                      </p:cBhvr>
+                                      <p:tavLst>
+                                        <p:tav tm="0">
+                                          <p:val>
+                                            <p:strVal val="#ppt_x"/>
+                                          </p:val>
+                                        </p:tav>
+                                        <p:tav tm="100000">
+                                          <p:val>
+                                            <p:strVal val="#ppt_x"/>
+                                          </p:val>
+                                        </p:tav>
+                                      </p:tavLst>
+                                    </p:anim>
+                                    <p:anim calcmode="lin" valueType="num">
+                                      <p:cBhvr additive="base">
+                                        <p:cTn id="26" dur="750" fill="hold"/>
+                                        <p:tgtEl>
+                                          <p:spTgt spid="3">
+                                            <p:txEl>
+                                              <p:pRg st="3" end="3"/>
+                                            </p:txEl>
+                                          </p:spTgt>
+                                        </p:tgtEl>
+                                        <p:attrNameLst>
+                                          <p:attrName>ppt_y</p:attrName>
+                                        </p:attrNameLst>
+                                      </p:cBhvr>
+                                      <p:tavLst>
+                                        <p:tav tm="0">
+                                          <p:val>
+                                            <p:strVal val="1+#ppt_h/2"/>
+                                          </p:val>
+                                        </p:tav>
+                                        <p:tav tm="100000">
+                                          <p:val>
+                                            <p:strVal val="#ppt_y"/>
+                                          </p:val>
+                                        </p:tav>
+                                      </p:tavLst>
+                                    </p:anim>
+                                  </p:childTnLst>
+                                </p:cTn>
+                              </p:par>
+                            </p:childTnLst>
+                          </p:cTn>
+                        </p:par>
+                      </p:childTnLst>
+                    </p:cTn>
+                  </p:par>
+                </p:childTnLst>
+              </p:cTn>
+              <p:prevCondLst>
+                <p:cond evt="onPrev" delay="0">
+                  <p:tgtEl>
+                    <p:sldTgt/>
+                  </p:tgtEl>
+                </p:cond>
+              </p:prevCondLst>
+              <p:nextCondLst>
+                <p:cond evt="onNext" delay="0">
+                  <p:tgtEl>
+                    <p:sldTgt/>
+                  </p:tgtEl>
+                </p:cond>
+              </p:nextCondLst>
+            </p:seq>
+          </p:childTnLst>
+        </p:cTn>
+      </p:par>
+    </p:tnLst>
+  </p:timing>
 </p:sld>
 </file>
 
 <file path=ppt/slides/slide9.xml><?xml version="1.0" encoding="utf-8"?>
-<p:sld xmlns:a="http://schemas.openxmlformats.org/drawingml/2006/main" xmlns:r="http://schemas.openxmlformats.org/officeDocument/2006/relationships" xmlns:p="http://schemas.openxmlformats.org/presentationml/2006/main">
+<p:sld xmlns:a="http://schemas.openxmlformats.org/drawingml/2006/main" xmlns:a14="http://schemas.microsoft.com/office/drawing/2010/main" xmlns:a16="http://schemas.microsoft.com/office/drawing/2014/main" xmlns:p="http://schemas.openxmlformats.org/presentationml/2006/main" xmlns:p14="http://schemas.microsoft.com/office/powerpoint/2010/main" xmlns:r="http://schemas.openxmlformats.org/officeDocument/2006/relationships">
   <p:cSld>
     <p:bg>
       <p:bgPr>
@@ -7833,7 +10023,7 @@
           <p:cNvPr id="2" name="Title 1" descr="dzrDfAqAW7ZgKunqIr74gqSi0ud1sWKkLcruswwVaq6dRWLK6GQP5K+exw8HmszjL4mRD48JMwwaL+KMa0DEgmP/ki01HH3F-~o9c34L+Z0Ax8ZIRhkTJFYw==">
             <a:extLst>
               <a:ext uri="{FF2B5EF4-FFF2-40B4-BE49-F238E27FC236}">
-                <a16:creationId xmlns:a16="http://schemas.microsoft.com/office/drawing/2014/main" id="{6E32CB19-CC60-4758-8E36-88BF6DFEBAE2}"/>
+                <a16:creationId id="{6E32CB19-CC60-4758-8E36-88BF6DFEBAE2}"/>
               </a:ext>
             </a:extLst>
           </p:cNvPr>
@@ -7889,7 +10079,7 @@
           <p:cNvPr id="33" name="Group 32" descr="5qtY3w5oBPmLilQkBEIUPPdis8OiiBzgfBu9SGdC9P8iJuIETZvQb13mxGvgE0RLtrXuDZzo2acFj+XoW98komEvTGrBxra9-~p2b3gjkQfEzFmBZSPMabiA==">
             <a:extLst>
               <a:ext uri="{FF2B5EF4-FFF2-40B4-BE49-F238E27FC236}">
-                <a16:creationId xmlns:a16="http://schemas.microsoft.com/office/drawing/2014/main" id="{5C2EB8D4-BE63-4C33-80EA-527029067816}"/>
+                <a16:creationId id="{5C2EB8D4-BE63-4C33-80EA-527029067816}"/>
               </a:ext>
             </a:extLst>
           </p:cNvPr>
@@ -7909,7 +10099,7 @@
             <p:cNvPr id="5" name="Oval 4" descr="K6VQgMC39eZv1CXkpva1b29eqqqgDKS/sb86Dm+6T9xNi9KXx/AfZ1p2gPX3bmGg83sY4u0dQVZwx6Roi/BL1PF518K63XQB-~cWkaCe5Od+0A0SmF6CSP7g==">
               <a:extLst>
                 <a:ext uri="{FF2B5EF4-FFF2-40B4-BE49-F238E27FC236}">
-                  <a16:creationId xmlns:a16="http://schemas.microsoft.com/office/drawing/2014/main" id="{856232E9-D19D-4E6A-AE6B-C6303F23CE9A}"/>
+                  <a16:creationId id="{856232E9-D19D-4E6A-AE6B-C6303F23CE9A}"/>
                 </a:ext>
               </a:extLst>
             </p:cNvPr>
@@ -7982,7 +10172,7 @@
             <p:cNvPr id="7" name="Oval 6" descr="5BarFRW7qA2z2NCotsdAXvkHT6MMym533ivPYQD2PSpkHeNw6ceZPBHu5Co9pS7meyLUftAIqYK2I89gzXSvjYvbnx81HMOO-~ddn+9yPiX0B6tYK002B5mw==">
               <a:extLst>
                 <a:ext uri="{FF2B5EF4-FFF2-40B4-BE49-F238E27FC236}">
-                  <a16:creationId xmlns:a16="http://schemas.microsoft.com/office/drawing/2014/main" id="{DB80FA51-EFAD-4F49-8A47-9F2EEF9314F1}"/>
+                  <a16:creationId id="{DB80FA51-EFAD-4F49-8A47-9F2EEF9314F1}"/>
                 </a:ext>
               </a:extLst>
             </p:cNvPr>
@@ -8055,7 +10245,7 @@
             <p:cNvPr id="9" name="Oval 8" descr="Hd1wBOcHKGGQGlMgxM+7kAi3fld4jAFcpvEkqAKuBatLrO1BoGphb6sW7vXS28ZJkbzavGbnLvSGf/e1z1RnywcGUleIuQ3O-~9zF8QPQVCmlBgjRgrmqD+g==">
               <a:extLst>
                 <a:ext uri="{FF2B5EF4-FFF2-40B4-BE49-F238E27FC236}">
-                  <a16:creationId xmlns:a16="http://schemas.microsoft.com/office/drawing/2014/main" id="{7566F67A-6142-443A-91F2-52305B8EEDC9}"/>
+                  <a16:creationId id="{7566F67A-6142-443A-91F2-52305B8EEDC9}"/>
                 </a:ext>
               </a:extLst>
             </p:cNvPr>
@@ -8128,7 +10318,7 @@
             <p:cNvPr id="11" name="Oval 10" descr="8aZhGYJsuam/XvRDshT5mhQ5mdyQdckzJ8/uaMvRxvAABFnZHG+ftjvUcEOr7WOpcopljvBU+u5f5NvGzYVvhb7PqNiZx4d8-~72Y17Ej2peq2FV2QaHxwmw==">
               <a:extLst>
                 <a:ext uri="{FF2B5EF4-FFF2-40B4-BE49-F238E27FC236}">
-                  <a16:creationId xmlns:a16="http://schemas.microsoft.com/office/drawing/2014/main" id="{ABFDBA04-8C06-4FB7-B378-222FD0A6F2B1}"/>
+                  <a16:creationId id="{ABFDBA04-8C06-4FB7-B378-222FD0A6F2B1}"/>
                 </a:ext>
               </a:extLst>
             </p:cNvPr>
@@ -8201,7 +10391,7 @@
             <p:cNvPr id="13" name="Oval 12" descr="lDSBX0cEoU9QTOfnpOfkhW+9vs+5d5YTQMr0PsvFwAQjok+RwctLaBz/xVfz9rIDUGQ0nCVEtg4dSxfY68Lkg+VXfkMKJdmc-~UAKanz0NBkO9W9CSL890og==">
               <a:extLst>
                 <a:ext uri="{FF2B5EF4-FFF2-40B4-BE49-F238E27FC236}">
-                  <a16:creationId xmlns:a16="http://schemas.microsoft.com/office/drawing/2014/main" id="{B1073ABB-AB6F-4A68-958F-AB3E04E3DF67}"/>
+                  <a16:creationId id="{B1073ABB-AB6F-4A68-958F-AB3E04E3DF67}"/>
                 </a:ext>
               </a:extLst>
             </p:cNvPr>
@@ -8274,7 +10464,7 @@
             <p:cNvPr id="15" name="Oval 14" descr="LYKWnJhbsTR7TEcX0VVXkORLAfUGzPp3DGAYi1TzTB+25m++JVVAhqpZtXLekJSA2SSkrnqzTbEFuwyYK9HM5IgDl1isGsaw-~DPvscVyqvxDZaonOeR41dQ==">
               <a:extLst>
                 <a:ext uri="{FF2B5EF4-FFF2-40B4-BE49-F238E27FC236}">
-                  <a16:creationId xmlns:a16="http://schemas.microsoft.com/office/drawing/2014/main" id="{681E8FAD-AFCB-41A8-9D23-62AA399F2DB9}"/>
+                  <a16:creationId id="{681E8FAD-AFCB-41A8-9D23-62AA399F2DB9}"/>
                 </a:ext>
               </a:extLst>
             </p:cNvPr>
@@ -8348,7 +10538,7 @@
           <p:cNvPr id="32" name="Group 31" descr="FzYHmxp7CwcOMkgsJ6nZtm9NQE573IYeNePbRysH0Wy/1gzmnsYHjHz/aoHMqQO6Ue+ts5r+9c5pOBzwTP9ojpO38iZhCDlA-~HQpStr3VbdzmTv6H31bkDw==">
             <a:extLst>
               <a:ext uri="{FF2B5EF4-FFF2-40B4-BE49-F238E27FC236}">
-                <a16:creationId xmlns:a16="http://schemas.microsoft.com/office/drawing/2014/main" id="{BE4EAAA5-B2D2-4048-BC6C-38BDC9F32957}"/>
+                <a16:creationId id="{BE4EAAA5-B2D2-4048-BC6C-38BDC9F32957}"/>
               </a:ext>
             </a:extLst>
           </p:cNvPr>
@@ -8368,7 +10558,7 @@
             <p:cNvPr id="17" name="Isosceles Triangle 16" descr="FuOcoyj29WodiPqsOKR3EB3d32UyicuiJ/7rwS22ntjrx7MgLE40i40Qyc+TpDROfuDJhsv70bGV8RQaw/G92FSbmHZ5xEMR-~g7CJkaz7Lc3Kf8lpKkaowg==">
               <a:extLst>
                 <a:ext uri="{FF2B5EF4-FFF2-40B4-BE49-F238E27FC236}">
-                  <a16:creationId xmlns:a16="http://schemas.microsoft.com/office/drawing/2014/main" id="{B9CB8281-485D-49D6-B031-DA8FEC698BE6}"/>
+                  <a16:creationId id="{B9CB8281-485D-49D6-B031-DA8FEC698BE6}"/>
                 </a:ext>
               </a:extLst>
             </p:cNvPr>
@@ -8441,7 +10631,7 @@
             <p:cNvPr id="19" name="Isosceles Triangle 18" descr="RAZDbjOmzpAt9kAYr5gMmBrDCyqQNhAogfG/zWw8QKw25yP+KS/+o4IAGe2ynkBid1DmmRA+V6HRKcv29JOwW+fR1Pe4gKFX-~RhRv0Gf+EAknlry8MumsOQ==">
               <a:extLst>
                 <a:ext uri="{FF2B5EF4-FFF2-40B4-BE49-F238E27FC236}">
-                  <a16:creationId xmlns:a16="http://schemas.microsoft.com/office/drawing/2014/main" id="{925A24EE-6942-476E-B0F8-70BF2D21BEB4}"/>
+                  <a16:creationId id="{925A24EE-6942-476E-B0F8-70BF2D21BEB4}"/>
                 </a:ext>
               </a:extLst>
             </p:cNvPr>
@@ -8514,7 +10704,7 @@
             <p:cNvPr id="21" name="Isosceles Triangle 20" descr="xPLkFjbaMoHalYUBtYYaC5C6etuQSJIWWpg+lCl9seo/qWjnI2LcYPJKwhyiQ4TdM8BmPNb4focCHDzNjJdBIjnviDf2pUjc-~+18NfEwe9ZsEBh8AUTAM6w==">
               <a:extLst>
                 <a:ext uri="{FF2B5EF4-FFF2-40B4-BE49-F238E27FC236}">
-                  <a16:creationId xmlns:a16="http://schemas.microsoft.com/office/drawing/2014/main" id="{5B85721D-7AB6-4370-9B6D-DC5283DCF640}"/>
+                  <a16:creationId id="{5B85721D-7AB6-4370-9B6D-DC5283DCF640}"/>
                 </a:ext>
               </a:extLst>
             </p:cNvPr>
@@ -8588,7 +10778,7 @@
           <p:cNvPr id="34" name="Group 33" descr="ywt5fALqk/ln3fZ422TfxQ3AF18rzdM0WO0QWACKXxFAAS9jVFPps09XW6bWPkPHzD6mmMq5G4pQAzo8j+R5btDgavFMT2E2-~ESoDSlkY7DvZpawOXiSmUA==">
             <a:extLst>
               <a:ext uri="{FF2B5EF4-FFF2-40B4-BE49-F238E27FC236}">
-                <a16:creationId xmlns:a16="http://schemas.microsoft.com/office/drawing/2014/main" id="{858ED6CF-4F9A-4CC3-AFB9-6FE719AE310B}"/>
+                <a16:creationId id="{858ED6CF-4F9A-4CC3-AFB9-6FE719AE310B}"/>
               </a:ext>
             </a:extLst>
           </p:cNvPr>
@@ -8608,7 +10798,7 @@
             <p:cNvPr id="23" name="Rounded Rectangle 12" descr="UK8X9kU9goz7IouhPZ+0tPM1HnE1rfPV4tA1xq9FIz1+LMMbNywPTwJHdfCh5+zoOS204RBj9zwY2doIHktQJnO5P/RgOqlC-~htpXPEoqntgtcyip2SkXrw==">
               <a:extLst>
                 <a:ext uri="{FF2B5EF4-FFF2-40B4-BE49-F238E27FC236}">
-                  <a16:creationId xmlns:a16="http://schemas.microsoft.com/office/drawing/2014/main" id="{C7D06C0D-F97B-4209-9F3E-00F3991C708C}"/>
+                  <a16:creationId id="{C7D06C0D-F97B-4209-9F3E-00F3991C708C}"/>
                 </a:ext>
               </a:extLst>
             </p:cNvPr>
@@ -8681,7 +10871,7 @@
             <p:cNvPr id="25" name="Rounded Rectangle 13" descr="Y4yMRdPexKqNGL2i+AQs/4SzECB1VVj5eCboQ+USOR98W9uhvPDbuNXUTkbokADB4XNnrL5GA7XhkPNA0nrGqZTfGtObnoXe-~zPSymtGe244DnoLx3J7yDw==">
               <a:extLst>
                 <a:ext uri="{FF2B5EF4-FFF2-40B4-BE49-F238E27FC236}">
-                  <a16:creationId xmlns:a16="http://schemas.microsoft.com/office/drawing/2014/main" id="{6480102B-63DA-4E57-8F89-4C38D2C41020}"/>
+                  <a16:creationId id="{6480102B-63DA-4E57-8F89-4C38D2C41020}"/>
                 </a:ext>
               </a:extLst>
             </p:cNvPr>
@@ -8754,7 +10944,7 @@
             <p:cNvPr id="27" name="Rounded Rectangle 14" descr="+zMw+6Y0Ik8TFeezo4M/JEXgJGOK/2PpnSXi2JCqzI9PU6isycyBdJxIlF4gapTE5a8vpSllJJCJIAkuVUo4hcynRwDGJ5an-~FICpDI51AQdgRZ654kFm0w==">
               <a:extLst>
                 <a:ext uri="{FF2B5EF4-FFF2-40B4-BE49-F238E27FC236}">
-                  <a16:creationId xmlns:a16="http://schemas.microsoft.com/office/drawing/2014/main" id="{8C5EF8E2-4462-40B4-AC4D-06088C0575E0}"/>
+                  <a16:creationId id="{8C5EF8E2-4462-40B4-AC4D-06088C0575E0}"/>
                 </a:ext>
               </a:extLst>
             </p:cNvPr>
@@ -8827,7 +11017,7 @@
             <p:cNvPr id="29" name="Rounded Rectangle 15" descr="XU+9i/WYTA9j6lbnI3RR+fk3PSFiFlSeUqHfM7he2xgwF+w0KfBnBz/g+LpEuSVzHMDNzMXKka2apAP1WnjXBQdVh/l5bqpP-~kzb+7dNpI9rp6RFoaGIImQ==">
               <a:extLst>
                 <a:ext uri="{FF2B5EF4-FFF2-40B4-BE49-F238E27FC236}">
-                  <a16:creationId xmlns:a16="http://schemas.microsoft.com/office/drawing/2014/main" id="{45BAE9B3-9ACC-4C9D-8052-E84C1AF9A85E}"/>
+                  <a16:creationId id="{45BAE9B3-9ACC-4C9D-8052-E84C1AF9A85E}"/>
                 </a:ext>
               </a:extLst>
             </p:cNvPr>
@@ -8900,7 +11090,7 @@
             <p:cNvPr id="31" name="Rounded Rectangle 16" descr="r+I4WuAeb6oJCA53k4L9zJb7f06QqL8oCCwJUOBiPrCSyBGwgSgqwDJX/EEhW7NbFogAcKIoWtyoWHVIZZk069sfuHtscANy-~hUbMJA3xI0ekSyL5ALkK7Q==">
               <a:extLst>
                 <a:ext uri="{FF2B5EF4-FFF2-40B4-BE49-F238E27FC236}">
-                  <a16:creationId xmlns:a16="http://schemas.microsoft.com/office/drawing/2014/main" id="{74EAF735-FAB5-469C-9751-C7CB126592F1}"/>
+                  <a16:creationId id="{74EAF735-FAB5-469C-9751-C7CB126592F1}"/>
                 </a:ext>
               </a:extLst>
             </p:cNvPr>
@@ -8974,7 +11164,7 @@
           <p:cNvPr id="36" name="Picture 35#@#WTbnkxJZpZM0XACQLdswLOgVYGBMa0XKr83pkjb4bJmNhd1Bj4MMOhU+JqBVeLJIlJLrNjc2CD8VNmkAej6ALI8u0tlP1Opu-~q3LkQh5J3x2TLvhQOiFaXg==" descr="A picture containing food, drawing, flower&#10;&#10;Description automatically generated">
             <a:extLst>
               <a:ext uri="{FF2B5EF4-FFF2-40B4-BE49-F238E27FC236}">
-                <a16:creationId xmlns:a16="http://schemas.microsoft.com/office/drawing/2014/main" id="{2B0C1C6E-0764-44F3-872B-9C1D2B94CBFA}"/>
+                <a16:creationId id="{2B0C1C6E-0764-44F3-872B-9C1D2B94CBFA}"/>
               </a:ext>
             </a:extLst>
           </p:cNvPr>
@@ -8987,7 +11177,7 @@
           <a:blip r:embed="rId3">
             <a:extLst>
               <a:ext uri="{28A0092B-C50C-407E-A947-70E740481C1C}">
-                <a14:useLocalDpi xmlns:a14="http://schemas.microsoft.com/office/drawing/2010/main"/>
+                <a14:useLocalDpi/>
               </a:ext>
             </a:extLst>
           </a:blip>
@@ -9008,13 +11198,16 @@
     </p:spTree>
     <p:extLst>
       <p:ext uri="{BB962C8B-B14F-4D97-AF65-F5344CB8AC3E}">
-        <p14:creationId xmlns:p14="http://schemas.microsoft.com/office/powerpoint/2010/main" val="1701843948"/>
+        <p14:creationId val="1701843948"/>
       </p:ext>
     </p:extLst>
   </p:cSld>
   <p:clrMapOvr>
     <a:masterClrMapping/>
   </p:clrMapOvr>
+  <p:transition>
+    <p14:cube dir="d"/>
+  </p:transition>
 </p:sld>
 </file>
 

</xml_diff>